<commit_message>
Update PPT template to v3 + restore agenda-slide cloning rules
New Basic Presentation Template.pptx adds a dedicated Agenda slide at
index 1 (Light - Main, 5 pill rows + 3 stacked photos) and pushes the
End slide to index 7. Other layouts and example slides are unchanged
in name and ordering.

SKILL.md changes:
- Step 3: rewrite the 8-slide structure table; mark slide 1 as the
  Agenda template and slide 7 as the End slide
- Step 4: re-introduce the Agenda cloning + pill-population workflow
  (clone, scan section-break titles, set the 5 pill texts in order)
- All "end slide index 6" references updated to index 7
- Add "never rebuild the agenda slide from a blank layout" to the
  What Not to Do list
- Update end-slide boilerplate description to "Aerospace Safety
  Intelligence Platform" to match the new template content
</commit_message>
<xml_diff>
--- a/.claude/skills/ppt-design-system/Basic Presentation Template.pptx
+++ b/.claude/skills/ppt-design-system/Basic Presentation Template.pptx
@@ -5,16 +5,17 @@
     <p:sldMasterId id="2147483654" r:id="rId4"/>
   </p:sldMasterIdLst>
   <p:notesMasterIdLst>
-    <p:notesMasterId r:id="rId12"/>
+    <p:notesMasterId r:id="rId13"/>
   </p:notesMasterIdLst>
   <p:sldIdLst>
     <p:sldId id="352" r:id="rId5"/>
-    <p:sldId id="316" r:id="rId6"/>
-    <p:sldId id="8527" r:id="rId7"/>
-    <p:sldId id="8522" r:id="rId8"/>
-    <p:sldId id="304" r:id="rId9"/>
-    <p:sldId id="305" r:id="rId10"/>
-    <p:sldId id="612" r:id="rId11"/>
+    <p:sldId id="920" r:id="rId6"/>
+    <p:sldId id="316" r:id="rId7"/>
+    <p:sldId id="8527" r:id="rId8"/>
+    <p:sldId id="8522" r:id="rId9"/>
+    <p:sldId id="304" r:id="rId10"/>
+    <p:sldId id="305" r:id="rId11"/>
+    <p:sldId id="612" r:id="rId12"/>
   </p:sldIdLst>
   <p:sldSz cx="12192000" cy="6858000"/>
   <p:notesSz cx="6858000" cy="9144000"/>
@@ -211,7 +212,7 @@
           <a:p>
             <a:fld id="{FD3DFF91-E63B-E948-B3A5-1D1BF1CECDF7}" type="datetimeFigureOut">
               <a:rPr lang="en-US" smtClean="0"/>
-              <a:t>5/19/26</a:t>
+              <a:t>5/22/26</a:t>
             </a:fld>
             <a:endParaRPr lang="en-US"/>
           </a:p>
@@ -637,7 +638,7 @@
           <a:p>
             <a:fld id="{BEB95CE4-0521-0C49-933F-6556F583EA40}" type="slidenum">
               <a:rPr lang="en-US" smtClean="0"/>
-              <a:t>3</a:t>
+              <a:t>4</a:t>
             </a:fld>
             <a:endParaRPr lang="en-US"/>
           </a:p>
@@ -721,7 +722,7 @@
           <a:p>
             <a:fld id="{BEB95CE4-0521-0C49-933F-6556F583EA40}" type="slidenum">
               <a:rPr lang="en-US" smtClean="0"/>
-              <a:t>4</a:t>
+              <a:t>5</a:t>
             </a:fld>
             <a:endParaRPr lang="en-US"/>
           </a:p>
@@ -8652,7 +8653,7 @@
           <a:p>
             <a:fld id="{C8A1BA17-5FCD-E84E-BA65-AF5582366495}" type="datetime4">
               <a:rPr lang="en-GB" smtClean="0"/>
-              <a:t>19 May 2026</a:t>
+              <a:t>22 May 2026</a:t>
             </a:fld>
             <a:endParaRPr lang="en-US" dirty="0"/>
           </a:p>
@@ -8690,10 +8691,171 @@
       </p:grpSpPr>
       <p:sp>
         <p:nvSpPr>
-          <p:cNvPr id="2" name="Title 1">
-            <a:extLst>
-              <a:ext uri="{FF2B5EF4-FFF2-40B4-BE49-F238E27FC236}">
-                <a16:creationId xmlns:a16="http://schemas.microsoft.com/office/drawing/2014/main" id="{B0B41E22-4416-A494-EF9C-ECE7F9361FFE}"/>
+          <p:cNvPr id="3" name="Slide Number Placeholder 2">
+            <a:extLst>
+              <a:ext uri="{FF2B5EF4-FFF2-40B4-BE49-F238E27FC236}">
+                <a16:creationId xmlns:a16="http://schemas.microsoft.com/office/drawing/2014/main" id="{49A5DCBC-D7F7-8B50-AFE7-C618D183F8D5}"/>
+              </a:ext>
+            </a:extLst>
+          </p:cNvPr>
+          <p:cNvSpPr>
+            <a:spLocks noGrp="1"/>
+          </p:cNvSpPr>
+          <p:nvPr>
+            <p:ph type="sldNum" sz="quarter" idx="4"/>
+          </p:nvPr>
+        </p:nvSpPr>
+        <p:spPr/>
+        <p:txBody>
+          <a:bodyPr/>
+          <a:lstStyle/>
+          <a:p>
+            <a:fld id="{1B377F6A-2966-294D-95D7-FBB58FDBE7CB}" type="slidenum">
+              <a:rPr lang="en-US" smtClean="0"/>
+              <a:pPr/>
+              <a:t>2</a:t>
+            </a:fld>
+            <a:endParaRPr lang="en-US"/>
+          </a:p>
+        </p:txBody>
+      </p:sp>
+      <p:sp>
+        <p:nvSpPr>
+          <p:cNvPr id="4" name="Footer Placeholder 3">
+            <a:extLst>
+              <a:ext uri="{FF2B5EF4-FFF2-40B4-BE49-F238E27FC236}">
+                <a16:creationId xmlns:a16="http://schemas.microsoft.com/office/drawing/2014/main" id="{C0382B3A-EB05-F3DF-CFA1-B5353CBBE6E4}"/>
+              </a:ext>
+            </a:extLst>
+          </p:cNvPr>
+          <p:cNvSpPr>
+            <a:spLocks noGrp="1"/>
+          </p:cNvSpPr>
+          <p:nvPr>
+            <p:ph type="ftr" sz="quarter" idx="3"/>
+          </p:nvPr>
+        </p:nvSpPr>
+        <p:spPr/>
+        <p:txBody>
+          <a:bodyPr/>
+          <a:lstStyle/>
+          <a:p>
+            <a:r>
+              <a:rPr lang="en-US"/>
+              <a:t>©</a:t>
+            </a:r>
+            <a:fld id="{3FEB6F09-2C38-294C-994A-AB349969DE87}" type="datetimeyyyy">
+              <a:rPr lang="en-GB" smtClean="0"/>
+              <a:pPr/>
+              <a:t>2026</a:t>
+            </a:fld>
+            <a:r>
+              <a:rPr lang="en-US"/>
+              <a:t> TrustFlight Ltd. All rights reserved. </a:t>
+            </a:r>
+            <a:endParaRPr lang="en-US" dirty="0"/>
+          </a:p>
+        </p:txBody>
+      </p:sp>
+      <p:pic>
+        <p:nvPicPr>
+          <p:cNvPr id="6" name="Picture 5" descr="A helicopter with a propeller&#10;&#10;Description automatically generated">
+            <a:extLst>
+              <a:ext uri="{FF2B5EF4-FFF2-40B4-BE49-F238E27FC236}">
+                <a16:creationId xmlns:a16="http://schemas.microsoft.com/office/drawing/2014/main" id="{CDE660C7-0AA5-CDC3-65E0-4E54E45FFC8A}"/>
+              </a:ext>
+            </a:extLst>
+          </p:cNvPr>
+          <p:cNvPicPr>
+            <a:picLocks noChangeAspect="1"/>
+          </p:cNvPicPr>
+          <p:nvPr/>
+        </p:nvPicPr>
+        <p:blipFill>
+          <a:blip r:embed="rId2"/>
+          <a:stretch>
+            <a:fillRect/>
+          </a:stretch>
+        </p:blipFill>
+        <p:spPr>
+          <a:xfrm rot="428508">
+            <a:off x="5535667" y="4502868"/>
+            <a:ext cx="3239570" cy="965508"/>
+          </a:xfrm>
+          <a:prstGeom prst="rect">
+            <a:avLst/>
+          </a:prstGeom>
+          <a:effectLst>
+            <a:reflection blurRad="6350" stA="15000" endPos="63000" dist="227611" dir="5400000" sy="-100000" algn="bl" rotWithShape="0"/>
+          </a:effectLst>
+        </p:spPr>
+      </p:pic>
+      <p:pic>
+        <p:nvPicPr>
+          <p:cNvPr id="7" name="Picture 6" descr="A close-up of a plane&#10;&#10;Description automatically generated">
+            <a:extLst>
+              <a:ext uri="{FF2B5EF4-FFF2-40B4-BE49-F238E27FC236}">
+                <a16:creationId xmlns:a16="http://schemas.microsoft.com/office/drawing/2014/main" id="{05746D87-88AB-3CDD-AB45-72641775C6B0}"/>
+              </a:ext>
+            </a:extLst>
+          </p:cNvPr>
+          <p:cNvPicPr>
+            <a:picLocks noChangeAspect="1"/>
+          </p:cNvPicPr>
+          <p:nvPr/>
+        </p:nvPicPr>
+        <p:blipFill>
+          <a:blip r:embed="rId3"/>
+          <a:stretch>
+            <a:fillRect/>
+          </a:stretch>
+        </p:blipFill>
+        <p:spPr>
+          <a:xfrm rot="21246488">
+            <a:off x="6598130" y="2078475"/>
+            <a:ext cx="4831589" cy="1606517"/>
+          </a:xfrm>
+          <a:prstGeom prst="rect">
+            <a:avLst/>
+          </a:prstGeom>
+        </p:spPr>
+      </p:pic>
+      <p:pic>
+        <p:nvPicPr>
+          <p:cNvPr id="8" name="Picture 7" descr="A blue and white airplane&#10;&#10;Description automatically generated">
+            <a:extLst>
+              <a:ext uri="{FF2B5EF4-FFF2-40B4-BE49-F238E27FC236}">
+                <a16:creationId xmlns:a16="http://schemas.microsoft.com/office/drawing/2014/main" id="{FE2B91CB-2B3D-F1F4-E46F-073912D9624E}"/>
+              </a:ext>
+            </a:extLst>
+          </p:cNvPr>
+          <p:cNvPicPr>
+            <a:picLocks noChangeAspect="1"/>
+          </p:cNvPicPr>
+          <p:nvPr/>
+        </p:nvPicPr>
+        <p:blipFill>
+          <a:blip r:embed="rId4"/>
+          <a:stretch>
+            <a:fillRect/>
+          </a:stretch>
+        </p:blipFill>
+        <p:spPr>
+          <a:xfrm rot="21212173">
+            <a:off x="5166270" y="633486"/>
+            <a:ext cx="3505063" cy="1128390"/>
+          </a:xfrm>
+          <a:prstGeom prst="rect">
+            <a:avLst/>
+          </a:prstGeom>
+        </p:spPr>
+      </p:pic>
+      <p:sp>
+        <p:nvSpPr>
+          <p:cNvPr id="9" name="Title 1">
+            <a:extLst>
+              <a:ext uri="{FF2B5EF4-FFF2-40B4-BE49-F238E27FC236}">
+                <a16:creationId xmlns:a16="http://schemas.microsoft.com/office/drawing/2014/main" id="{499761D1-0CEA-C763-534E-5778B8477917}"/>
               </a:ext>
             </a:extLst>
           </p:cNvPr>
@@ -8706,8 +8868,8 @@
         </p:nvSpPr>
         <p:spPr>
           <a:xfrm>
-            <a:off x="540001" y="2875002"/>
-            <a:ext cx="8331626" cy="553998"/>
+            <a:off x="540000" y="829399"/>
+            <a:ext cx="9462670" cy="553998"/>
           </a:xfrm>
         </p:spPr>
         <p:txBody>
@@ -8716,201 +8878,360 @@
           <a:p>
             <a:r>
               <a:rPr lang="en-US" sz="4000" dirty="0"/>
-              <a:t>Section Break</a:t>
-            </a:r>
-          </a:p>
-        </p:txBody>
-      </p:sp>
-      <p:sp>
-        <p:nvSpPr>
-          <p:cNvPr id="4" name="Slide Number Placeholder 3">
-            <a:extLst>
-              <a:ext uri="{FF2B5EF4-FFF2-40B4-BE49-F238E27FC236}">
-                <a16:creationId xmlns:a16="http://schemas.microsoft.com/office/drawing/2014/main" id="{CA7F385A-EDA9-765B-DCFE-F86BCA14F7AE}"/>
-              </a:ext>
-            </a:extLst>
-          </p:cNvPr>
-          <p:cNvSpPr>
-            <a:spLocks noGrp="1"/>
-          </p:cNvSpPr>
-          <p:nvPr>
-            <p:ph type="sldNum" sz="quarter" idx="4"/>
-          </p:nvPr>
-        </p:nvSpPr>
-        <p:spPr/>
-        <p:txBody>
-          <a:bodyPr/>
+              <a:t>Agenda</a:t>
+            </a:r>
+          </a:p>
+        </p:txBody>
+      </p:sp>
+      <p:sp>
+        <p:nvSpPr>
+          <p:cNvPr id="10" name="Google Shape;110;p16">
+            <a:extLst>
+              <a:ext uri="{FF2B5EF4-FFF2-40B4-BE49-F238E27FC236}">
+                <a16:creationId xmlns:a16="http://schemas.microsoft.com/office/drawing/2014/main" id="{A5B1C390-9E63-6667-A4ED-AE69B1C49F6F}"/>
+              </a:ext>
+            </a:extLst>
+          </p:cNvPr>
+          <p:cNvSpPr/>
+          <p:nvPr/>
+        </p:nvSpPr>
+        <p:spPr>
+          <a:xfrm>
+            <a:off x="-351034" y="2120862"/>
+            <a:ext cx="5212234" cy="666459"/>
+          </a:xfrm>
+          <a:prstGeom prst="roundRect">
+            <a:avLst>
+              <a:gd name="adj" fmla="val 50000"/>
+            </a:avLst>
+          </a:prstGeom>
+          <a:gradFill>
+            <a:gsLst>
+              <a:gs pos="0">
+                <a:srgbClr val="F2F7FF"/>
+              </a:gs>
+              <a:gs pos="100000">
+                <a:srgbClr val="FFFFFF"/>
+              </a:gs>
+            </a:gsLst>
+            <a:lin ang="13500000" scaled="0"/>
+          </a:gradFill>
+          <a:ln w="9525" cap="flat" cmpd="sng">
+            <a:solidFill>
+              <a:srgbClr val="CFE2F3"/>
+            </a:solidFill>
+            <a:prstDash val="solid"/>
+            <a:round/>
+            <a:headEnd type="none" w="sm" len="sm"/>
+            <a:tailEnd type="none" w="sm" len="sm"/>
+          </a:ln>
+        </p:spPr>
+        <p:txBody>
+          <a:bodyPr spcFirstLastPara="1" wrap="square" lIns="792000" tIns="91425" rIns="91425" bIns="91425" anchor="ctr" anchorCtr="0">
+            <a:noAutofit/>
+          </a:bodyPr>
           <a:lstStyle/>
           <a:p>
-            <a:fld id="{1B377F6A-2966-294D-95D7-FBB58FDBE7CB}" type="slidenum">
-              <a:rPr lang="en-US" smtClean="0"/>
-              <a:pPr/>
-              <a:t>2</a:t>
-            </a:fld>
-            <a:endParaRPr lang="en-US"/>
-          </a:p>
-        </p:txBody>
-      </p:sp>
-      <p:sp>
-        <p:nvSpPr>
-          <p:cNvPr id="3" name="Footer Placeholder 4">
-            <a:extLst>
-              <a:ext uri="{FF2B5EF4-FFF2-40B4-BE49-F238E27FC236}">
-                <a16:creationId xmlns:a16="http://schemas.microsoft.com/office/drawing/2014/main" id="{3B3D7ED2-BB62-C756-333E-8AFB5FFF1C43}"/>
-              </a:ext>
-            </a:extLst>
-          </p:cNvPr>
-          <p:cNvSpPr txBox="1">
-            <a:spLocks/>
-          </p:cNvSpPr>
+            <a:pPr>
+              <a:buClr>
+                <a:srgbClr val="1E5BB5"/>
+              </a:buClr>
+            </a:pPr>
+            <a:r>
+              <a:rPr lang="en-GB" b="1" dirty="0">
+                <a:solidFill>
+                  <a:srgbClr val="1E5BB5"/>
+                </a:solidFill>
+                <a:latin typeface="Open Sans SemiBold" pitchFamily="2" charset="0"/>
+                <a:ea typeface="Open Sans SemiBold" pitchFamily="2" charset="0"/>
+                <a:cs typeface="Open Sans SemiBold" pitchFamily="2" charset="0"/>
+                <a:sym typeface="Open Sans"/>
+              </a:rPr>
+              <a:t>Item 1</a:t>
+            </a:r>
+          </a:p>
+        </p:txBody>
+      </p:sp>
+      <p:sp>
+        <p:nvSpPr>
+          <p:cNvPr id="11" name="Google Shape;110;p16">
+            <a:extLst>
+              <a:ext uri="{FF2B5EF4-FFF2-40B4-BE49-F238E27FC236}">
+                <a16:creationId xmlns:a16="http://schemas.microsoft.com/office/drawing/2014/main" id="{7B392FFF-CE04-6F22-9868-A2E05725993E}"/>
+              </a:ext>
+            </a:extLst>
+          </p:cNvPr>
+          <p:cNvSpPr/>
           <p:nvPr/>
         </p:nvSpPr>
         <p:spPr>
           <a:xfrm>
-            <a:off x="540000" y="6461968"/>
-            <a:ext cx="3078186" cy="153888"/>
-          </a:xfrm>
-          <a:prstGeom prst="rect">
-            <a:avLst/>
-          </a:prstGeom>
-        </p:spPr>
-        <p:txBody>
-          <a:bodyPr vert="horz" wrap="square" lIns="0" tIns="0" rIns="0" bIns="0" rtlCol="0" anchor="ctr">
-            <a:spAutoFit/>
+            <a:off x="-351034" y="2869008"/>
+            <a:ext cx="5212234" cy="666459"/>
+          </a:xfrm>
+          <a:prstGeom prst="roundRect">
+            <a:avLst>
+              <a:gd name="adj" fmla="val 50000"/>
+            </a:avLst>
+          </a:prstGeom>
+          <a:gradFill>
+            <a:gsLst>
+              <a:gs pos="0">
+                <a:srgbClr val="F2F7FF"/>
+              </a:gs>
+              <a:gs pos="100000">
+                <a:srgbClr val="FFFFFF"/>
+              </a:gs>
+            </a:gsLst>
+            <a:lin ang="13500000" scaled="0"/>
+          </a:gradFill>
+          <a:ln w="9525" cap="flat" cmpd="sng">
+            <a:solidFill>
+              <a:srgbClr val="CFE2F3"/>
+            </a:solidFill>
+            <a:prstDash val="solid"/>
+            <a:round/>
+            <a:headEnd type="none" w="sm" len="sm"/>
+            <a:tailEnd type="none" w="sm" len="sm"/>
+          </a:ln>
+        </p:spPr>
+        <p:txBody>
+          <a:bodyPr spcFirstLastPara="1" wrap="square" lIns="792000" tIns="91425" rIns="91425" bIns="91425" anchor="ctr" anchorCtr="0">
+            <a:noAutofit/>
           </a:bodyPr>
-          <a:lstStyle>
-            <a:defPPr>
-              <a:defRPr lang="en-US"/>
-            </a:defPPr>
-            <a:lvl1pPr marL="0" algn="l" defTabSz="914355" rtl="0" eaLnBrk="1" latinLnBrk="0" hangingPunct="1">
-              <a:defRPr sz="1000" b="0" i="0" kern="1200">
-                <a:solidFill>
-                  <a:srgbClr val="242D41"/>
-                </a:solidFill>
-                <a:latin typeface="Open Sans Light" panose="020B0306030504020204" pitchFamily="34" charset="0"/>
-                <a:ea typeface="Open Sans Light" panose="020B0306030504020204" pitchFamily="34" charset="0"/>
-                <a:cs typeface="Open Sans Light" panose="020B0306030504020204" pitchFamily="34" charset="0"/>
-              </a:defRPr>
-            </a:lvl1pPr>
-            <a:lvl2pPr marL="457177" algn="l" defTabSz="914355" rtl="0" eaLnBrk="1" latinLnBrk="0" hangingPunct="1">
-              <a:defRPr sz="1800" kern="1200">
-                <a:solidFill>
-                  <a:schemeClr val="tx1"/>
-                </a:solidFill>
-                <a:latin typeface="+mn-lt"/>
-                <a:ea typeface="+mn-ea"/>
-                <a:cs typeface="+mn-cs"/>
-              </a:defRPr>
-            </a:lvl2pPr>
-            <a:lvl3pPr marL="914355" algn="l" defTabSz="914355" rtl="0" eaLnBrk="1" latinLnBrk="0" hangingPunct="1">
-              <a:defRPr sz="1800" kern="1200">
-                <a:solidFill>
-                  <a:schemeClr val="tx1"/>
-                </a:solidFill>
-                <a:latin typeface="+mn-lt"/>
-                <a:ea typeface="+mn-ea"/>
-                <a:cs typeface="+mn-cs"/>
-              </a:defRPr>
-            </a:lvl3pPr>
-            <a:lvl4pPr marL="1371532" algn="l" defTabSz="914355" rtl="0" eaLnBrk="1" latinLnBrk="0" hangingPunct="1">
-              <a:defRPr sz="1800" kern="1200">
-                <a:solidFill>
-                  <a:schemeClr val="tx1"/>
-                </a:solidFill>
-                <a:latin typeface="+mn-lt"/>
-                <a:ea typeface="+mn-ea"/>
-                <a:cs typeface="+mn-cs"/>
-              </a:defRPr>
-            </a:lvl4pPr>
-            <a:lvl5pPr marL="1828709" algn="l" defTabSz="914355" rtl="0" eaLnBrk="1" latinLnBrk="0" hangingPunct="1">
-              <a:defRPr sz="1800" kern="1200">
-                <a:solidFill>
-                  <a:schemeClr val="tx1"/>
-                </a:solidFill>
-                <a:latin typeface="+mn-lt"/>
-                <a:ea typeface="+mn-ea"/>
-                <a:cs typeface="+mn-cs"/>
-              </a:defRPr>
-            </a:lvl5pPr>
-            <a:lvl6pPr marL="2285886" algn="l" defTabSz="914355" rtl="0" eaLnBrk="1" latinLnBrk="0" hangingPunct="1">
-              <a:defRPr sz="1800" kern="1200">
-                <a:solidFill>
-                  <a:schemeClr val="tx1"/>
-                </a:solidFill>
-                <a:latin typeface="+mn-lt"/>
-                <a:ea typeface="+mn-ea"/>
-                <a:cs typeface="+mn-cs"/>
-              </a:defRPr>
-            </a:lvl6pPr>
-            <a:lvl7pPr marL="2743063" algn="l" defTabSz="914355" rtl="0" eaLnBrk="1" latinLnBrk="0" hangingPunct="1">
-              <a:defRPr sz="1800" kern="1200">
-                <a:solidFill>
-                  <a:schemeClr val="tx1"/>
-                </a:solidFill>
-                <a:latin typeface="+mn-lt"/>
-                <a:ea typeface="+mn-ea"/>
-                <a:cs typeface="+mn-cs"/>
-              </a:defRPr>
-            </a:lvl7pPr>
-            <a:lvl8pPr marL="3200240" algn="l" defTabSz="914355" rtl="0" eaLnBrk="1" latinLnBrk="0" hangingPunct="1">
-              <a:defRPr sz="1800" kern="1200">
-                <a:solidFill>
-                  <a:schemeClr val="tx1"/>
-                </a:solidFill>
-                <a:latin typeface="+mn-lt"/>
-                <a:ea typeface="+mn-ea"/>
-                <a:cs typeface="+mn-cs"/>
-              </a:defRPr>
-            </a:lvl8pPr>
-            <a:lvl9pPr marL="3657417" algn="l" defTabSz="914355" rtl="0" eaLnBrk="1" latinLnBrk="0" hangingPunct="1">
-              <a:defRPr sz="1800" kern="1200">
-                <a:solidFill>
-                  <a:schemeClr val="tx1"/>
-                </a:solidFill>
-                <a:latin typeface="+mn-lt"/>
-                <a:ea typeface="+mn-ea"/>
-                <a:cs typeface="+mn-cs"/>
-              </a:defRPr>
-            </a:lvl9pPr>
-          </a:lstStyle>
-          <a:p>
-            <a:r>
-              <a:rPr lang="en-US">
-                <a:solidFill>
-                  <a:srgbClr val="CFE2F3"/>
-                </a:solidFill>
+          <a:lstStyle/>
+          <a:p>
+            <a:pPr>
+              <a:buClr>
+                <a:srgbClr val="1E5BB5"/>
+              </a:buClr>
+            </a:pPr>
+            <a:r>
+              <a:rPr lang="en-GB" b="1" dirty="0">
+                <a:solidFill>
+                  <a:srgbClr val="1E5BB5"/>
+                </a:solidFill>
+                <a:latin typeface="Open Sans SemiBold" pitchFamily="2" charset="0"/>
+                <a:ea typeface="Open Sans SemiBold" pitchFamily="2" charset="0"/>
+                <a:cs typeface="Open Sans SemiBold" pitchFamily="2" charset="0"/>
+                <a:sym typeface="Open Sans"/>
               </a:rPr>
-              <a:t>©</a:t>
-            </a:r>
-            <a:fld id="{3FEB6F09-2C38-294C-994A-AB349969DE87}" type="datetimeyyyy">
-              <a:rPr lang="en-GB" smtClean="0">
-                <a:solidFill>
-                  <a:srgbClr val="CFE2F3"/>
-                </a:solidFill>
+              <a:t>Item 2</a:t>
+            </a:r>
+          </a:p>
+        </p:txBody>
+      </p:sp>
+      <p:sp>
+        <p:nvSpPr>
+          <p:cNvPr id="12" name="Google Shape;110;p16">
+            <a:extLst>
+              <a:ext uri="{FF2B5EF4-FFF2-40B4-BE49-F238E27FC236}">
+                <a16:creationId xmlns:a16="http://schemas.microsoft.com/office/drawing/2014/main" id="{898D6E48-4054-B90C-D21D-B19513906402}"/>
+              </a:ext>
+            </a:extLst>
+          </p:cNvPr>
+          <p:cNvSpPr/>
+          <p:nvPr/>
+        </p:nvSpPr>
+        <p:spPr>
+          <a:xfrm>
+            <a:off x="-351034" y="3617153"/>
+            <a:ext cx="5212234" cy="666459"/>
+          </a:xfrm>
+          <a:prstGeom prst="roundRect">
+            <a:avLst>
+              <a:gd name="adj" fmla="val 50000"/>
+            </a:avLst>
+          </a:prstGeom>
+          <a:gradFill>
+            <a:gsLst>
+              <a:gs pos="0">
+                <a:srgbClr val="F2F7FF"/>
+              </a:gs>
+              <a:gs pos="100000">
+                <a:srgbClr val="FFFFFF"/>
+              </a:gs>
+            </a:gsLst>
+            <a:lin ang="13500000" scaled="0"/>
+          </a:gradFill>
+          <a:ln w="9525" cap="flat" cmpd="sng">
+            <a:solidFill>
+              <a:srgbClr val="CFE2F3"/>
+            </a:solidFill>
+            <a:prstDash val="solid"/>
+            <a:round/>
+            <a:headEnd type="none" w="sm" len="sm"/>
+            <a:tailEnd type="none" w="sm" len="sm"/>
+          </a:ln>
+        </p:spPr>
+        <p:txBody>
+          <a:bodyPr spcFirstLastPara="1" wrap="square" lIns="792000" tIns="91425" rIns="91425" bIns="91425" anchor="ctr" anchorCtr="0">
+            <a:noAutofit/>
+          </a:bodyPr>
+          <a:lstStyle/>
+          <a:p>
+            <a:pPr>
+              <a:buClr>
+                <a:srgbClr val="1E5BB5"/>
+              </a:buClr>
+            </a:pPr>
+            <a:r>
+              <a:rPr lang="en-GB" b="1" dirty="0">
+                <a:solidFill>
+                  <a:srgbClr val="1E5BB5"/>
+                </a:solidFill>
+                <a:latin typeface="Open Sans SemiBold" pitchFamily="2" charset="0"/>
+                <a:ea typeface="Open Sans SemiBold" pitchFamily="2" charset="0"/>
+                <a:cs typeface="Open Sans SemiBold" pitchFamily="2" charset="0"/>
+                <a:sym typeface="Open Sans"/>
               </a:rPr>
-              <a:pPr/>
-              <a:t>2026</a:t>
-            </a:fld>
-            <a:r>
-              <a:rPr lang="en-US">
-                <a:solidFill>
-                  <a:srgbClr val="CFE2F3"/>
-                </a:solidFill>
+              <a:t>Item 3</a:t>
+            </a:r>
+          </a:p>
+        </p:txBody>
+      </p:sp>
+      <p:sp>
+        <p:nvSpPr>
+          <p:cNvPr id="13" name="Google Shape;110;p16">
+            <a:extLst>
+              <a:ext uri="{FF2B5EF4-FFF2-40B4-BE49-F238E27FC236}">
+                <a16:creationId xmlns:a16="http://schemas.microsoft.com/office/drawing/2014/main" id="{956B4C66-97D5-FE92-971B-27FAA394C287}"/>
+              </a:ext>
+            </a:extLst>
+          </p:cNvPr>
+          <p:cNvSpPr/>
+          <p:nvPr/>
+        </p:nvSpPr>
+        <p:spPr>
+          <a:xfrm>
+            <a:off x="-351034" y="4365299"/>
+            <a:ext cx="5212234" cy="666459"/>
+          </a:xfrm>
+          <a:prstGeom prst="roundRect">
+            <a:avLst>
+              <a:gd name="adj" fmla="val 50000"/>
+            </a:avLst>
+          </a:prstGeom>
+          <a:gradFill>
+            <a:gsLst>
+              <a:gs pos="0">
+                <a:srgbClr val="F2F7FF"/>
+              </a:gs>
+              <a:gs pos="100000">
+                <a:srgbClr val="FFFFFF"/>
+              </a:gs>
+            </a:gsLst>
+            <a:lin ang="13500000" scaled="0"/>
+          </a:gradFill>
+          <a:ln w="9525" cap="flat" cmpd="sng">
+            <a:solidFill>
+              <a:srgbClr val="CFE2F3"/>
+            </a:solidFill>
+            <a:prstDash val="solid"/>
+            <a:round/>
+            <a:headEnd type="none" w="sm" len="sm"/>
+            <a:tailEnd type="none" w="sm" len="sm"/>
+          </a:ln>
+        </p:spPr>
+        <p:txBody>
+          <a:bodyPr spcFirstLastPara="1" wrap="square" lIns="792000" tIns="91425" rIns="91425" bIns="91425" anchor="ctr" anchorCtr="0">
+            <a:noAutofit/>
+          </a:bodyPr>
+          <a:lstStyle/>
+          <a:p>
+            <a:pPr>
+              <a:buClr>
+                <a:srgbClr val="1E5BB5"/>
+              </a:buClr>
+            </a:pPr>
+            <a:r>
+              <a:rPr lang="en-GB" b="1" dirty="0">
+                <a:solidFill>
+                  <a:srgbClr val="1E5BB5"/>
+                </a:solidFill>
+                <a:latin typeface="Open Sans SemiBold" pitchFamily="2" charset="0"/>
+                <a:ea typeface="Open Sans SemiBold" pitchFamily="2" charset="0"/>
+                <a:cs typeface="Open Sans SemiBold" pitchFamily="2" charset="0"/>
+                <a:sym typeface="Open Sans"/>
               </a:rPr>
-              <a:t> TrustFlight Ltd. All rights reserved. </a:t>
-            </a:r>
-            <a:endParaRPr lang="en-US" dirty="0">
-              <a:solidFill>
-                <a:srgbClr val="CFE2F3"/>
-              </a:solidFill>
-            </a:endParaRPr>
+              <a:t>Item 4</a:t>
+            </a:r>
+          </a:p>
+        </p:txBody>
+      </p:sp>
+      <p:sp>
+        <p:nvSpPr>
+          <p:cNvPr id="14" name="Google Shape;110;p16">
+            <a:extLst>
+              <a:ext uri="{FF2B5EF4-FFF2-40B4-BE49-F238E27FC236}">
+                <a16:creationId xmlns:a16="http://schemas.microsoft.com/office/drawing/2014/main" id="{3F0E9F40-EF00-9DC1-3A06-95F66587E57C}"/>
+              </a:ext>
+            </a:extLst>
+          </p:cNvPr>
+          <p:cNvSpPr/>
+          <p:nvPr/>
+        </p:nvSpPr>
+        <p:spPr>
+          <a:xfrm>
+            <a:off x="-351034" y="5113444"/>
+            <a:ext cx="5212234" cy="666459"/>
+          </a:xfrm>
+          <a:prstGeom prst="roundRect">
+            <a:avLst>
+              <a:gd name="adj" fmla="val 50000"/>
+            </a:avLst>
+          </a:prstGeom>
+          <a:gradFill>
+            <a:gsLst>
+              <a:gs pos="0">
+                <a:srgbClr val="F2F7FF"/>
+              </a:gs>
+              <a:gs pos="100000">
+                <a:srgbClr val="FFFFFF"/>
+              </a:gs>
+            </a:gsLst>
+            <a:lin ang="13500000" scaled="0"/>
+          </a:gradFill>
+          <a:ln w="9525" cap="flat" cmpd="sng">
+            <a:solidFill>
+              <a:srgbClr val="CFE2F3"/>
+            </a:solidFill>
+            <a:prstDash val="solid"/>
+            <a:round/>
+            <a:headEnd type="none" w="sm" len="sm"/>
+            <a:tailEnd type="none" w="sm" len="sm"/>
+          </a:ln>
+        </p:spPr>
+        <p:txBody>
+          <a:bodyPr spcFirstLastPara="1" wrap="square" lIns="792000" tIns="91425" rIns="91425" bIns="91425" anchor="ctr" anchorCtr="0">
+            <a:noAutofit/>
+          </a:bodyPr>
+          <a:lstStyle/>
+          <a:p>
+            <a:pPr>
+              <a:buClr>
+                <a:srgbClr val="1E5BB5"/>
+              </a:buClr>
+            </a:pPr>
+            <a:r>
+              <a:rPr lang="en-GB" b="1" dirty="0">
+                <a:solidFill>
+                  <a:srgbClr val="1E5BB5"/>
+                </a:solidFill>
+                <a:latin typeface="Open Sans SemiBold" pitchFamily="2" charset="0"/>
+                <a:ea typeface="Open Sans SemiBold" pitchFamily="2" charset="0"/>
+                <a:cs typeface="Open Sans SemiBold" pitchFamily="2" charset="0"/>
+                <a:sym typeface="Open Sans"/>
+              </a:rPr>
+              <a:t>Item 5</a:t>
+            </a:r>
           </a:p>
         </p:txBody>
       </p:sp>
     </p:spTree>
     <p:extLst>
       <p:ext uri="{BB962C8B-B14F-4D97-AF65-F5344CB8AC3E}">
-        <p14:creationId xmlns:p14="http://schemas.microsoft.com/office/powerpoint/2010/main" val="3450649577"/>
+        <p14:creationId xmlns:p14="http://schemas.microsoft.com/office/powerpoint/2010/main" val="1684320835"/>
       </p:ext>
     </p:extLst>
   </p:cSld>
@@ -8939,10 +9260,43 @@
       </p:grpSpPr>
       <p:sp>
         <p:nvSpPr>
-          <p:cNvPr id="2" name="Slide Number Placeholder 1">
-            <a:extLst>
-              <a:ext uri="{FF2B5EF4-FFF2-40B4-BE49-F238E27FC236}">
-                <a16:creationId xmlns:a16="http://schemas.microsoft.com/office/drawing/2014/main" id="{C166096B-8C46-3BA2-D97C-4E2EE038240C}"/>
+          <p:cNvPr id="2" name="Title 1">
+            <a:extLst>
+              <a:ext uri="{FF2B5EF4-FFF2-40B4-BE49-F238E27FC236}">
+                <a16:creationId xmlns:a16="http://schemas.microsoft.com/office/drawing/2014/main" id="{B0B41E22-4416-A494-EF9C-ECE7F9361FFE}"/>
+              </a:ext>
+            </a:extLst>
+          </p:cNvPr>
+          <p:cNvSpPr>
+            <a:spLocks noGrp="1"/>
+          </p:cNvSpPr>
+          <p:nvPr>
+            <p:ph type="title"/>
+          </p:nvPr>
+        </p:nvSpPr>
+        <p:spPr>
+          <a:xfrm>
+            <a:off x="540001" y="2875002"/>
+            <a:ext cx="8331626" cy="553998"/>
+          </a:xfrm>
+        </p:spPr>
+        <p:txBody>
+          <a:bodyPr/>
+          <a:lstStyle/>
+          <a:p>
+            <a:r>
+              <a:rPr lang="en-US" sz="4000" dirty="0"/>
+              <a:t>Section Break</a:t>
+            </a:r>
+          </a:p>
+        </p:txBody>
+      </p:sp>
+      <p:sp>
+        <p:nvSpPr>
+          <p:cNvPr id="4" name="Slide Number Placeholder 3">
+            <a:extLst>
+              <a:ext uri="{FF2B5EF4-FFF2-40B4-BE49-F238E27FC236}">
+                <a16:creationId xmlns:a16="http://schemas.microsoft.com/office/drawing/2014/main" id="{CA7F385A-EDA9-765B-DCFE-F86BCA14F7AE}"/>
               </a:ext>
             </a:extLst>
           </p:cNvPr>
@@ -8963,127 +9317,170 @@
               <a:pPr/>
               <a:t>3</a:t>
             </a:fld>
-            <a:endParaRPr lang="en-US" dirty="0"/>
-          </a:p>
-        </p:txBody>
-      </p:sp>
-      <p:sp>
-        <p:nvSpPr>
-          <p:cNvPr id="3" name="Footer Placeholder 2">
-            <a:extLst>
-              <a:ext uri="{FF2B5EF4-FFF2-40B4-BE49-F238E27FC236}">
-                <a16:creationId xmlns:a16="http://schemas.microsoft.com/office/drawing/2014/main" id="{975C10E2-09F7-A408-DABC-D88E6FD3C20D}"/>
-              </a:ext>
-            </a:extLst>
-          </p:cNvPr>
-          <p:cNvSpPr>
-            <a:spLocks noGrp="1"/>
+            <a:endParaRPr lang="en-US"/>
+          </a:p>
+        </p:txBody>
+      </p:sp>
+      <p:sp>
+        <p:nvSpPr>
+          <p:cNvPr id="3" name="Footer Placeholder 4">
+            <a:extLst>
+              <a:ext uri="{FF2B5EF4-FFF2-40B4-BE49-F238E27FC236}">
+                <a16:creationId xmlns:a16="http://schemas.microsoft.com/office/drawing/2014/main" id="{3B3D7ED2-BB62-C756-333E-8AFB5FFF1C43}"/>
+              </a:ext>
+            </a:extLst>
+          </p:cNvPr>
+          <p:cNvSpPr txBox="1">
+            <a:spLocks/>
           </p:cNvSpPr>
-          <p:nvPr>
-            <p:ph type="ftr" sz="quarter" idx="3"/>
-          </p:nvPr>
-        </p:nvSpPr>
-        <p:spPr/>
-        <p:txBody>
-          <a:bodyPr/>
-          <a:lstStyle/>
-          <a:p>
-            <a:r>
-              <a:rPr lang="en-US" dirty="0"/>
+          <p:nvPr/>
+        </p:nvSpPr>
+        <p:spPr>
+          <a:xfrm>
+            <a:off x="540000" y="6461968"/>
+            <a:ext cx="3078186" cy="153888"/>
+          </a:xfrm>
+          <a:prstGeom prst="rect">
+            <a:avLst/>
+          </a:prstGeom>
+        </p:spPr>
+        <p:txBody>
+          <a:bodyPr vert="horz" wrap="square" lIns="0" tIns="0" rIns="0" bIns="0" rtlCol="0" anchor="ctr">
+            <a:spAutoFit/>
+          </a:bodyPr>
+          <a:lstStyle>
+            <a:defPPr>
+              <a:defRPr lang="en-US"/>
+            </a:defPPr>
+            <a:lvl1pPr marL="0" algn="l" defTabSz="914355" rtl="0" eaLnBrk="1" latinLnBrk="0" hangingPunct="1">
+              <a:defRPr sz="1000" b="0" i="0" kern="1200">
+                <a:solidFill>
+                  <a:srgbClr val="242D41"/>
+                </a:solidFill>
+                <a:latin typeface="Open Sans Light" panose="020B0306030504020204" pitchFamily="34" charset="0"/>
+                <a:ea typeface="Open Sans Light" panose="020B0306030504020204" pitchFamily="34" charset="0"/>
+                <a:cs typeface="Open Sans Light" panose="020B0306030504020204" pitchFamily="34" charset="0"/>
+              </a:defRPr>
+            </a:lvl1pPr>
+            <a:lvl2pPr marL="457177" algn="l" defTabSz="914355" rtl="0" eaLnBrk="1" latinLnBrk="0" hangingPunct="1">
+              <a:defRPr sz="1800" kern="1200">
+                <a:solidFill>
+                  <a:schemeClr val="tx1"/>
+                </a:solidFill>
+                <a:latin typeface="+mn-lt"/>
+                <a:ea typeface="+mn-ea"/>
+                <a:cs typeface="+mn-cs"/>
+              </a:defRPr>
+            </a:lvl2pPr>
+            <a:lvl3pPr marL="914355" algn="l" defTabSz="914355" rtl="0" eaLnBrk="1" latinLnBrk="0" hangingPunct="1">
+              <a:defRPr sz="1800" kern="1200">
+                <a:solidFill>
+                  <a:schemeClr val="tx1"/>
+                </a:solidFill>
+                <a:latin typeface="+mn-lt"/>
+                <a:ea typeface="+mn-ea"/>
+                <a:cs typeface="+mn-cs"/>
+              </a:defRPr>
+            </a:lvl3pPr>
+            <a:lvl4pPr marL="1371532" algn="l" defTabSz="914355" rtl="0" eaLnBrk="1" latinLnBrk="0" hangingPunct="1">
+              <a:defRPr sz="1800" kern="1200">
+                <a:solidFill>
+                  <a:schemeClr val="tx1"/>
+                </a:solidFill>
+                <a:latin typeface="+mn-lt"/>
+                <a:ea typeface="+mn-ea"/>
+                <a:cs typeface="+mn-cs"/>
+              </a:defRPr>
+            </a:lvl4pPr>
+            <a:lvl5pPr marL="1828709" algn="l" defTabSz="914355" rtl="0" eaLnBrk="1" latinLnBrk="0" hangingPunct="1">
+              <a:defRPr sz="1800" kern="1200">
+                <a:solidFill>
+                  <a:schemeClr val="tx1"/>
+                </a:solidFill>
+                <a:latin typeface="+mn-lt"/>
+                <a:ea typeface="+mn-ea"/>
+                <a:cs typeface="+mn-cs"/>
+              </a:defRPr>
+            </a:lvl5pPr>
+            <a:lvl6pPr marL="2285886" algn="l" defTabSz="914355" rtl="0" eaLnBrk="1" latinLnBrk="0" hangingPunct="1">
+              <a:defRPr sz="1800" kern="1200">
+                <a:solidFill>
+                  <a:schemeClr val="tx1"/>
+                </a:solidFill>
+                <a:latin typeface="+mn-lt"/>
+                <a:ea typeface="+mn-ea"/>
+                <a:cs typeface="+mn-cs"/>
+              </a:defRPr>
+            </a:lvl6pPr>
+            <a:lvl7pPr marL="2743063" algn="l" defTabSz="914355" rtl="0" eaLnBrk="1" latinLnBrk="0" hangingPunct="1">
+              <a:defRPr sz="1800" kern="1200">
+                <a:solidFill>
+                  <a:schemeClr val="tx1"/>
+                </a:solidFill>
+                <a:latin typeface="+mn-lt"/>
+                <a:ea typeface="+mn-ea"/>
+                <a:cs typeface="+mn-cs"/>
+              </a:defRPr>
+            </a:lvl7pPr>
+            <a:lvl8pPr marL="3200240" algn="l" defTabSz="914355" rtl="0" eaLnBrk="1" latinLnBrk="0" hangingPunct="1">
+              <a:defRPr sz="1800" kern="1200">
+                <a:solidFill>
+                  <a:schemeClr val="tx1"/>
+                </a:solidFill>
+                <a:latin typeface="+mn-lt"/>
+                <a:ea typeface="+mn-ea"/>
+                <a:cs typeface="+mn-cs"/>
+              </a:defRPr>
+            </a:lvl8pPr>
+            <a:lvl9pPr marL="3657417" algn="l" defTabSz="914355" rtl="0" eaLnBrk="1" latinLnBrk="0" hangingPunct="1">
+              <a:defRPr sz="1800" kern="1200">
+                <a:solidFill>
+                  <a:schemeClr val="tx1"/>
+                </a:solidFill>
+                <a:latin typeface="+mn-lt"/>
+                <a:ea typeface="+mn-ea"/>
+                <a:cs typeface="+mn-cs"/>
+              </a:defRPr>
+            </a:lvl9pPr>
+          </a:lstStyle>
+          <a:p>
+            <a:r>
+              <a:rPr lang="en-US">
+                <a:solidFill>
+                  <a:srgbClr val="CFE2F3"/>
+                </a:solidFill>
+              </a:rPr>
               <a:t>©</a:t>
             </a:r>
             <a:fld id="{3FEB6F09-2C38-294C-994A-AB349969DE87}" type="datetimeyyyy">
-              <a:rPr lang="en-GB" smtClean="0"/>
+              <a:rPr lang="en-GB" smtClean="0">
+                <a:solidFill>
+                  <a:srgbClr val="CFE2F3"/>
+                </a:solidFill>
+              </a:rPr>
               <a:pPr/>
               <a:t>2026</a:t>
             </a:fld>
             <a:r>
-              <a:rPr lang="en-US" dirty="0"/>
+              <a:rPr lang="en-US">
+                <a:solidFill>
+                  <a:srgbClr val="CFE2F3"/>
+                </a:solidFill>
+              </a:rPr>
               <a:t> TrustFlight Ltd. All rights reserved. </a:t>
             </a:r>
-          </a:p>
-        </p:txBody>
-      </p:sp>
-      <p:sp>
-        <p:nvSpPr>
-          <p:cNvPr id="8" name="Title 7">
-            <a:extLst>
-              <a:ext uri="{FF2B5EF4-FFF2-40B4-BE49-F238E27FC236}">
-                <a16:creationId xmlns:a16="http://schemas.microsoft.com/office/drawing/2014/main" id="{44940188-9A3A-52A9-CA08-A8EAC059D15B}"/>
-              </a:ext>
-            </a:extLst>
-          </p:cNvPr>
-          <p:cNvSpPr>
-            <a:spLocks noGrp="1"/>
-          </p:cNvSpPr>
-          <p:nvPr>
-            <p:ph type="title"/>
-          </p:nvPr>
-        </p:nvSpPr>
-        <p:spPr>
-          <a:xfrm>
-            <a:off x="540000" y="774000"/>
-            <a:ext cx="9462670" cy="553998"/>
-          </a:xfrm>
-        </p:spPr>
-        <p:txBody>
-          <a:bodyPr/>
-          <a:lstStyle/>
-          <a:p>
-            <a:r>
-              <a:rPr lang="en-US" sz="4000" dirty="0"/>
-              <a:t>Slide Title</a:t>
-            </a:r>
-          </a:p>
-        </p:txBody>
-      </p:sp>
-      <p:sp>
-        <p:nvSpPr>
-          <p:cNvPr id="9" name="TextBox 8">
-            <a:extLst>
-              <a:ext uri="{FF2B5EF4-FFF2-40B4-BE49-F238E27FC236}">
-                <a16:creationId xmlns:a16="http://schemas.microsoft.com/office/drawing/2014/main" id="{022D7855-27A0-05F0-C6A3-FAE31F47933A}"/>
-              </a:ext>
-            </a:extLst>
-          </p:cNvPr>
-          <p:cNvSpPr txBox="1"/>
-          <p:nvPr/>
-        </p:nvSpPr>
-        <p:spPr>
-          <a:xfrm>
-            <a:off x="546099" y="1376160"/>
-            <a:ext cx="9396187" cy="307777"/>
-          </a:xfrm>
-          <a:prstGeom prst="rect">
-            <a:avLst/>
-          </a:prstGeom>
-          <a:noFill/>
-        </p:spPr>
-        <p:txBody>
-          <a:bodyPr vertOverflow="overflow" vert="horz" wrap="square" lIns="0" tIns="0" rIns="0" bIns="0" rtlCol="0" anchor="t">
-            <a:spAutoFit/>
-          </a:bodyPr>
-          <a:lstStyle/>
-          <a:p>
-            <a:pPr algn="l"/>
-            <a:r>
-              <a:rPr lang="en-US" sz="2000" dirty="0">
-                <a:solidFill>
-                  <a:srgbClr val="479FF8"/>
-                </a:solidFill>
-                <a:latin typeface="Open Sans SemiBold" pitchFamily="2" charset="0"/>
-                <a:ea typeface="Open Sans SemiBold" pitchFamily="2" charset="0"/>
-                <a:cs typeface="Open Sans SemiBold" pitchFamily="2" charset="0"/>
-              </a:rPr>
-              <a:t>Slide subtitle</a:t>
-            </a:r>
+            <a:endParaRPr lang="en-US" dirty="0">
+              <a:solidFill>
+                <a:srgbClr val="CFE2F3"/>
+              </a:solidFill>
+            </a:endParaRPr>
           </a:p>
         </p:txBody>
       </p:sp>
     </p:spTree>
     <p:extLst>
       <p:ext uri="{BB962C8B-B14F-4D97-AF65-F5344CB8AC3E}">
-        <p14:creationId xmlns:p14="http://schemas.microsoft.com/office/powerpoint/2010/main" val="1296111721"/>
+        <p14:creationId xmlns:p14="http://schemas.microsoft.com/office/powerpoint/2010/main" val="3450649577"/>
       </p:ext>
     </p:extLst>
   </p:cSld>
@@ -9179,6 +9576,179 @@
       </p:sp>
       <p:sp>
         <p:nvSpPr>
+          <p:cNvPr id="8" name="Title 7">
+            <a:extLst>
+              <a:ext uri="{FF2B5EF4-FFF2-40B4-BE49-F238E27FC236}">
+                <a16:creationId xmlns:a16="http://schemas.microsoft.com/office/drawing/2014/main" id="{44940188-9A3A-52A9-CA08-A8EAC059D15B}"/>
+              </a:ext>
+            </a:extLst>
+          </p:cNvPr>
+          <p:cNvSpPr>
+            <a:spLocks noGrp="1"/>
+          </p:cNvSpPr>
+          <p:nvPr>
+            <p:ph type="title"/>
+          </p:nvPr>
+        </p:nvSpPr>
+        <p:spPr>
+          <a:xfrm>
+            <a:off x="540000" y="774000"/>
+            <a:ext cx="9462670" cy="553998"/>
+          </a:xfrm>
+        </p:spPr>
+        <p:txBody>
+          <a:bodyPr/>
+          <a:lstStyle/>
+          <a:p>
+            <a:r>
+              <a:rPr lang="en-US" sz="4000" dirty="0"/>
+              <a:t>Slide Title</a:t>
+            </a:r>
+          </a:p>
+        </p:txBody>
+      </p:sp>
+      <p:sp>
+        <p:nvSpPr>
+          <p:cNvPr id="9" name="TextBox 8">
+            <a:extLst>
+              <a:ext uri="{FF2B5EF4-FFF2-40B4-BE49-F238E27FC236}">
+                <a16:creationId xmlns:a16="http://schemas.microsoft.com/office/drawing/2014/main" id="{022D7855-27A0-05F0-C6A3-FAE31F47933A}"/>
+              </a:ext>
+            </a:extLst>
+          </p:cNvPr>
+          <p:cNvSpPr txBox="1"/>
+          <p:nvPr/>
+        </p:nvSpPr>
+        <p:spPr>
+          <a:xfrm>
+            <a:off x="546099" y="1376160"/>
+            <a:ext cx="9396187" cy="307777"/>
+          </a:xfrm>
+          <a:prstGeom prst="rect">
+            <a:avLst/>
+          </a:prstGeom>
+          <a:noFill/>
+        </p:spPr>
+        <p:txBody>
+          <a:bodyPr vertOverflow="overflow" vert="horz" wrap="square" lIns="0" tIns="0" rIns="0" bIns="0" rtlCol="0" anchor="t">
+            <a:spAutoFit/>
+          </a:bodyPr>
+          <a:lstStyle/>
+          <a:p>
+            <a:pPr algn="l"/>
+            <a:r>
+              <a:rPr lang="en-US" sz="2000" dirty="0">
+                <a:solidFill>
+                  <a:srgbClr val="479FF8"/>
+                </a:solidFill>
+                <a:latin typeface="Open Sans SemiBold" pitchFamily="2" charset="0"/>
+                <a:ea typeface="Open Sans SemiBold" pitchFamily="2" charset="0"/>
+                <a:cs typeface="Open Sans SemiBold" pitchFamily="2" charset="0"/>
+              </a:rPr>
+              <a:t>Slide subtitle</a:t>
+            </a:r>
+          </a:p>
+        </p:txBody>
+      </p:sp>
+    </p:spTree>
+    <p:extLst>
+      <p:ext uri="{BB962C8B-B14F-4D97-AF65-F5344CB8AC3E}">
+        <p14:creationId xmlns:p14="http://schemas.microsoft.com/office/powerpoint/2010/main" val="1296111721"/>
+      </p:ext>
+    </p:extLst>
+  </p:cSld>
+  <p:clrMapOvr>
+    <a:masterClrMapping/>
+  </p:clrMapOvr>
+</p:sld>
+</file>
+
+<file path=ppt/slides/slide5.xml><?xml version="1.0" encoding="utf-8"?>
+<p:sld xmlns:a="http://schemas.openxmlformats.org/drawingml/2006/main" xmlns:r="http://schemas.openxmlformats.org/officeDocument/2006/relationships" xmlns:p="http://schemas.openxmlformats.org/presentationml/2006/main">
+  <p:cSld>
+    <p:spTree>
+      <p:nvGrpSpPr>
+        <p:cNvPr id="1" name=""/>
+        <p:cNvGrpSpPr/>
+        <p:nvPr/>
+      </p:nvGrpSpPr>
+      <p:grpSpPr>
+        <a:xfrm>
+          <a:off x="0" y="0"/>
+          <a:ext cx="0" cy="0"/>
+          <a:chOff x="0" y="0"/>
+          <a:chExt cx="0" cy="0"/>
+        </a:xfrm>
+      </p:grpSpPr>
+      <p:sp>
+        <p:nvSpPr>
+          <p:cNvPr id="2" name="Slide Number Placeholder 1">
+            <a:extLst>
+              <a:ext uri="{FF2B5EF4-FFF2-40B4-BE49-F238E27FC236}">
+                <a16:creationId xmlns:a16="http://schemas.microsoft.com/office/drawing/2014/main" id="{C166096B-8C46-3BA2-D97C-4E2EE038240C}"/>
+              </a:ext>
+            </a:extLst>
+          </p:cNvPr>
+          <p:cNvSpPr>
+            <a:spLocks noGrp="1"/>
+          </p:cNvSpPr>
+          <p:nvPr>
+            <p:ph type="sldNum" sz="quarter" idx="4"/>
+          </p:nvPr>
+        </p:nvSpPr>
+        <p:spPr/>
+        <p:txBody>
+          <a:bodyPr/>
+          <a:lstStyle/>
+          <a:p>
+            <a:fld id="{1B377F6A-2966-294D-95D7-FBB58FDBE7CB}" type="slidenum">
+              <a:rPr lang="en-US" smtClean="0"/>
+              <a:pPr/>
+              <a:t>5</a:t>
+            </a:fld>
+            <a:endParaRPr lang="en-US" dirty="0"/>
+          </a:p>
+        </p:txBody>
+      </p:sp>
+      <p:sp>
+        <p:nvSpPr>
+          <p:cNvPr id="3" name="Footer Placeholder 2">
+            <a:extLst>
+              <a:ext uri="{FF2B5EF4-FFF2-40B4-BE49-F238E27FC236}">
+                <a16:creationId xmlns:a16="http://schemas.microsoft.com/office/drawing/2014/main" id="{975C10E2-09F7-A408-DABC-D88E6FD3C20D}"/>
+              </a:ext>
+            </a:extLst>
+          </p:cNvPr>
+          <p:cNvSpPr>
+            <a:spLocks noGrp="1"/>
+          </p:cNvSpPr>
+          <p:nvPr>
+            <p:ph type="ftr" sz="quarter" idx="3"/>
+          </p:nvPr>
+        </p:nvSpPr>
+        <p:spPr/>
+        <p:txBody>
+          <a:bodyPr/>
+          <a:lstStyle/>
+          <a:p>
+            <a:r>
+              <a:rPr lang="en-US" dirty="0"/>
+              <a:t>©</a:t>
+            </a:r>
+            <a:fld id="{3FEB6F09-2C38-294C-994A-AB349969DE87}" type="datetimeyyyy">
+              <a:rPr lang="en-GB" smtClean="0"/>
+              <a:pPr/>
+              <a:t>2026</a:t>
+            </a:fld>
+            <a:r>
+              <a:rPr lang="en-US" dirty="0"/>
+              <a:t> TrustFlight Ltd. All rights reserved. </a:t>
+            </a:r>
+          </a:p>
+        </p:txBody>
+      </p:sp>
+      <p:sp>
+        <p:nvSpPr>
           <p:cNvPr id="10" name="Title 7">
             <a:extLst>
               <a:ext uri="{FF2B5EF4-FFF2-40B4-BE49-F238E27FC236}">
@@ -9266,7 +9836,7 @@
 </p:sld>
 </file>
 
-<file path=ppt/slides/slide5.xml><?xml version="1.0" encoding="utf-8"?>
+<file path=ppt/slides/slide6.xml><?xml version="1.0" encoding="utf-8"?>
 <p:sld xmlns:a="http://schemas.openxmlformats.org/drawingml/2006/main" xmlns:r="http://schemas.openxmlformats.org/officeDocument/2006/relationships" xmlns:p="http://schemas.openxmlformats.org/presentationml/2006/main">
   <p:cSld>
     <p:bg>
@@ -9363,7 +9933,7 @@
             <a:fld id="{1B377F6A-2966-294D-95D7-FBB58FDBE7CB}" type="slidenum">
               <a:rPr lang="en-US" smtClean="0"/>
               <a:pPr/>
-              <a:t>5</a:t>
+              <a:t>6</a:t>
             </a:fld>
             <a:endParaRPr lang="en-US"/>
           </a:p>
@@ -9439,399 +10009,6 @@
     <p:extLst>
       <p:ext uri="{BB962C8B-B14F-4D97-AF65-F5344CB8AC3E}">
         <p14:creationId xmlns:p14="http://schemas.microsoft.com/office/powerpoint/2010/main" val="2701429794"/>
-      </p:ext>
-    </p:extLst>
-  </p:cSld>
-  <p:clrMapOvr>
-    <a:masterClrMapping/>
-  </p:clrMapOvr>
-</p:sld>
-</file>
-
-<file path=ppt/slides/slide6.xml><?xml version="1.0" encoding="utf-8"?>
-<p:sld xmlns:a="http://schemas.openxmlformats.org/drawingml/2006/main" xmlns:r="http://schemas.openxmlformats.org/officeDocument/2006/relationships" xmlns:p="http://schemas.openxmlformats.org/presentationml/2006/main">
-  <p:cSld>
-    <p:spTree>
-      <p:nvGrpSpPr>
-        <p:cNvPr id="1" name=""/>
-        <p:cNvGrpSpPr/>
-        <p:nvPr/>
-      </p:nvGrpSpPr>
-      <p:grpSpPr>
-        <a:xfrm>
-          <a:off x="0" y="0"/>
-          <a:ext cx="0" cy="0"/>
-          <a:chOff x="0" y="0"/>
-          <a:chExt cx="0" cy="0"/>
-        </a:xfrm>
-      </p:grpSpPr>
-      <p:sp>
-        <p:nvSpPr>
-          <p:cNvPr id="2" name="Title 1">
-            <a:extLst>
-              <a:ext uri="{FF2B5EF4-FFF2-40B4-BE49-F238E27FC236}">
-                <a16:creationId xmlns:a16="http://schemas.microsoft.com/office/drawing/2014/main" id="{D7142FB2-D27B-8EA1-E477-92FB93D5906E}"/>
-              </a:ext>
-            </a:extLst>
-          </p:cNvPr>
-          <p:cNvSpPr>
-            <a:spLocks noGrp="1"/>
-          </p:cNvSpPr>
-          <p:nvPr>
-            <p:ph type="title"/>
-          </p:nvPr>
-        </p:nvSpPr>
-        <p:spPr>
-          <a:xfrm>
-            <a:off x="540000" y="774000"/>
-            <a:ext cx="9462670" cy="553998"/>
-          </a:xfrm>
-        </p:spPr>
-        <p:txBody>
-          <a:bodyPr/>
-          <a:lstStyle/>
-          <a:p>
-            <a:r>
-              <a:rPr lang="en-US" sz="4000" dirty="0"/>
-              <a:t>Slide Title</a:t>
-            </a:r>
-          </a:p>
-        </p:txBody>
-      </p:sp>
-      <p:sp>
-        <p:nvSpPr>
-          <p:cNvPr id="5" name="Slide Number Placeholder 4">
-            <a:extLst>
-              <a:ext uri="{FF2B5EF4-FFF2-40B4-BE49-F238E27FC236}">
-                <a16:creationId xmlns:a16="http://schemas.microsoft.com/office/drawing/2014/main" id="{68562A10-B3FE-CCD6-3B68-053CD49D0462}"/>
-              </a:ext>
-            </a:extLst>
-          </p:cNvPr>
-          <p:cNvSpPr>
-            <a:spLocks noGrp="1"/>
-          </p:cNvSpPr>
-          <p:nvPr>
-            <p:ph type="sldNum" sz="quarter" idx="4"/>
-          </p:nvPr>
-        </p:nvSpPr>
-        <p:spPr/>
-        <p:txBody>
-          <a:bodyPr/>
-          <a:lstStyle/>
-          <a:p>
-            <a:fld id="{1B377F6A-2966-294D-95D7-FBB58FDBE7CB}" type="slidenum">
-              <a:rPr lang="en-US" smtClean="0"/>
-              <a:pPr/>
-              <a:t>6</a:t>
-            </a:fld>
-            <a:endParaRPr lang="en-US"/>
-          </a:p>
-        </p:txBody>
-      </p:sp>
-      <p:sp>
-        <p:nvSpPr>
-          <p:cNvPr id="12" name="Content Placeholder 4">
-            <a:extLst>
-              <a:ext uri="{FF2B5EF4-FFF2-40B4-BE49-F238E27FC236}">
-                <a16:creationId xmlns:a16="http://schemas.microsoft.com/office/drawing/2014/main" id="{7A6A3014-D139-ED15-CA4C-45DFB26D1B85}"/>
-              </a:ext>
-            </a:extLst>
-          </p:cNvPr>
-          <p:cNvSpPr txBox="1">
-            <a:spLocks/>
-          </p:cNvSpPr>
-          <p:nvPr/>
-        </p:nvSpPr>
-        <p:spPr>
-          <a:xfrm>
-            <a:off x="540000" y="1382429"/>
-            <a:ext cx="6905829" cy="215444"/>
-          </a:xfrm>
-          <a:prstGeom prst="rect">
-            <a:avLst/>
-          </a:prstGeom>
-        </p:spPr>
-        <p:txBody>
-          <a:bodyPr vert="horz" wrap="square" lIns="0" tIns="0" rIns="0" bIns="0" rtlCol="0">
-            <a:spAutoFit/>
-          </a:bodyPr>
-          <a:lstStyle>
-            <a:lvl1pPr marL="228589" indent="-228589" algn="l" defTabSz="914355" rtl="0" eaLnBrk="1" latinLnBrk="0" hangingPunct="1">
-              <a:lnSpc>
-                <a:spcPct val="90000"/>
-              </a:lnSpc>
-              <a:spcBef>
-                <a:spcPts val="1000"/>
-              </a:spcBef>
-              <a:buClr>
-                <a:srgbClr val="1E5BB5"/>
-              </a:buClr>
-              <a:buFont typeface="Arial" panose="020B0604020202020204" pitchFamily="34" charset="0"/>
-              <a:buChar char="•"/>
-              <a:defRPr sz="2400" b="0" i="0" kern="1200">
-                <a:solidFill>
-                  <a:schemeClr val="bg1"/>
-                </a:solidFill>
-                <a:latin typeface="Open Sans Light" panose="020B0606030504020204" pitchFamily="34" charset="0"/>
-                <a:ea typeface="Open Sans Light" panose="020B0606030504020204" pitchFamily="34" charset="0"/>
-                <a:cs typeface="Open Sans Light" panose="020B0606030504020204" pitchFamily="34" charset="0"/>
-              </a:defRPr>
-            </a:lvl1pPr>
-            <a:lvl2pPr marL="685766" indent="-228589" algn="l" defTabSz="914355" rtl="0" eaLnBrk="1" latinLnBrk="0" hangingPunct="1">
-              <a:lnSpc>
-                <a:spcPct val="90000"/>
-              </a:lnSpc>
-              <a:spcBef>
-                <a:spcPts val="500"/>
-              </a:spcBef>
-              <a:buClr>
-                <a:srgbClr val="1E5BB5"/>
-              </a:buClr>
-              <a:buFont typeface="Arial" panose="020B0604020202020204" pitchFamily="34" charset="0"/>
-              <a:buChar char="•"/>
-              <a:defRPr sz="1400" b="0" i="0" kern="1200">
-                <a:solidFill>
-                  <a:srgbClr val="E0E8F7"/>
-                </a:solidFill>
-                <a:latin typeface="Open Sans Light" panose="020B0606030504020204" pitchFamily="34" charset="0"/>
-                <a:ea typeface="Open Sans Light" panose="020B0606030504020204" pitchFamily="34" charset="0"/>
-                <a:cs typeface="Open Sans Light" panose="020B0606030504020204" pitchFamily="34" charset="0"/>
-              </a:defRPr>
-            </a:lvl2pPr>
-            <a:lvl3pPr marL="1142943" indent="-228589" algn="l" defTabSz="914355" rtl="0" eaLnBrk="1" latinLnBrk="0" hangingPunct="1">
-              <a:lnSpc>
-                <a:spcPct val="90000"/>
-              </a:lnSpc>
-              <a:spcBef>
-                <a:spcPts val="500"/>
-              </a:spcBef>
-              <a:buClr>
-                <a:srgbClr val="1E5BB5"/>
-              </a:buClr>
-              <a:buFont typeface="Arial" panose="020B0604020202020204" pitchFamily="34" charset="0"/>
-              <a:buChar char="•"/>
-              <a:defRPr sz="1400" b="0" i="0" kern="1200">
-                <a:solidFill>
-                  <a:srgbClr val="E0E8F7"/>
-                </a:solidFill>
-                <a:latin typeface="Open Sans Light" panose="020B0606030504020204" pitchFamily="34" charset="0"/>
-                <a:ea typeface="Open Sans Light" panose="020B0606030504020204" pitchFamily="34" charset="0"/>
-                <a:cs typeface="Open Sans Light" panose="020B0606030504020204" pitchFamily="34" charset="0"/>
-              </a:defRPr>
-            </a:lvl3pPr>
-            <a:lvl4pPr marL="1600120" indent="-228589" algn="l" defTabSz="914355" rtl="0" eaLnBrk="1" latinLnBrk="0" hangingPunct="1">
-              <a:lnSpc>
-                <a:spcPct val="90000"/>
-              </a:lnSpc>
-              <a:spcBef>
-                <a:spcPts val="500"/>
-              </a:spcBef>
-              <a:buClr>
-                <a:srgbClr val="1E5BB5"/>
-              </a:buClr>
-              <a:buFont typeface="Arial" panose="020B0604020202020204" pitchFamily="34" charset="0"/>
-              <a:buChar char="•"/>
-              <a:defRPr sz="1400" b="0" i="0" kern="1200">
-                <a:solidFill>
-                  <a:srgbClr val="E0E8F7"/>
-                </a:solidFill>
-                <a:latin typeface="Open Sans Light" panose="020B0606030504020204" pitchFamily="34" charset="0"/>
-                <a:ea typeface="Open Sans Light" panose="020B0606030504020204" pitchFamily="34" charset="0"/>
-                <a:cs typeface="Open Sans Light" panose="020B0606030504020204" pitchFamily="34" charset="0"/>
-              </a:defRPr>
-            </a:lvl4pPr>
-            <a:lvl5pPr marL="2057297" indent="-228589" algn="l" defTabSz="914355" rtl="0" eaLnBrk="1" latinLnBrk="0" hangingPunct="1">
-              <a:lnSpc>
-                <a:spcPct val="90000"/>
-              </a:lnSpc>
-              <a:spcBef>
-                <a:spcPts val="500"/>
-              </a:spcBef>
-              <a:buClr>
-                <a:srgbClr val="1E5BB5"/>
-              </a:buClr>
-              <a:buFont typeface="Arial" panose="020B0604020202020204" pitchFamily="34" charset="0"/>
-              <a:buChar char="•"/>
-              <a:defRPr sz="1400" b="0" i="0" kern="1200">
-                <a:solidFill>
-                  <a:srgbClr val="E0E8F7"/>
-                </a:solidFill>
-                <a:latin typeface="Open Sans Light" panose="020B0606030504020204" pitchFamily="34" charset="0"/>
-                <a:ea typeface="Open Sans Light" panose="020B0606030504020204" pitchFamily="34" charset="0"/>
-                <a:cs typeface="Open Sans Light" panose="020B0606030504020204" pitchFamily="34" charset="0"/>
-              </a:defRPr>
-            </a:lvl5pPr>
-            <a:lvl6pPr marL="2514475" indent="-228589" algn="l" defTabSz="914355" rtl="0" eaLnBrk="1" latinLnBrk="0" hangingPunct="1">
-              <a:lnSpc>
-                <a:spcPct val="90000"/>
-              </a:lnSpc>
-              <a:spcBef>
-                <a:spcPts val="500"/>
-              </a:spcBef>
-              <a:buFont typeface="Arial" panose="020B0604020202020204" pitchFamily="34" charset="0"/>
-              <a:buChar char="•"/>
-              <a:defRPr sz="1800" kern="1200">
-                <a:solidFill>
-                  <a:schemeClr val="tx1"/>
-                </a:solidFill>
-                <a:latin typeface="+mn-lt"/>
-                <a:ea typeface="+mn-ea"/>
-                <a:cs typeface="+mn-cs"/>
-              </a:defRPr>
-            </a:lvl6pPr>
-            <a:lvl7pPr marL="2971652" indent="-228589" algn="l" defTabSz="914355" rtl="0" eaLnBrk="1" latinLnBrk="0" hangingPunct="1">
-              <a:lnSpc>
-                <a:spcPct val="90000"/>
-              </a:lnSpc>
-              <a:spcBef>
-                <a:spcPts val="500"/>
-              </a:spcBef>
-              <a:buFont typeface="Arial" panose="020B0604020202020204" pitchFamily="34" charset="0"/>
-              <a:buChar char="•"/>
-              <a:defRPr sz="1800" kern="1200">
-                <a:solidFill>
-                  <a:schemeClr val="tx1"/>
-                </a:solidFill>
-                <a:latin typeface="+mn-lt"/>
-                <a:ea typeface="+mn-ea"/>
-                <a:cs typeface="+mn-cs"/>
-              </a:defRPr>
-            </a:lvl7pPr>
-            <a:lvl8pPr marL="3428829" indent="-228589" algn="l" defTabSz="914355" rtl="0" eaLnBrk="1" latinLnBrk="0" hangingPunct="1">
-              <a:lnSpc>
-                <a:spcPct val="90000"/>
-              </a:lnSpc>
-              <a:spcBef>
-                <a:spcPts val="500"/>
-              </a:spcBef>
-              <a:buFont typeface="Arial" panose="020B0604020202020204" pitchFamily="34" charset="0"/>
-              <a:buChar char="•"/>
-              <a:defRPr sz="1800" kern="1200">
-                <a:solidFill>
-                  <a:schemeClr val="tx1"/>
-                </a:solidFill>
-                <a:latin typeface="+mn-lt"/>
-                <a:ea typeface="+mn-ea"/>
-                <a:cs typeface="+mn-cs"/>
-              </a:defRPr>
-            </a:lvl8pPr>
-            <a:lvl9pPr marL="3886006" indent="-228589" algn="l" defTabSz="914355" rtl="0" eaLnBrk="1" latinLnBrk="0" hangingPunct="1">
-              <a:lnSpc>
-                <a:spcPct val="90000"/>
-              </a:lnSpc>
-              <a:spcBef>
-                <a:spcPts val="500"/>
-              </a:spcBef>
-              <a:buFont typeface="Arial" panose="020B0604020202020204" pitchFamily="34" charset="0"/>
-              <a:buChar char="•"/>
-              <a:defRPr sz="1800" kern="1200">
-                <a:solidFill>
-                  <a:schemeClr val="tx1"/>
-                </a:solidFill>
-                <a:latin typeface="+mn-lt"/>
-                <a:ea typeface="+mn-ea"/>
-                <a:cs typeface="+mn-cs"/>
-              </a:defRPr>
-            </a:lvl9pPr>
-          </a:lstStyle>
-          <a:p>
-            <a:pPr marL="0" indent="0">
-              <a:lnSpc>
-                <a:spcPct val="100000"/>
-              </a:lnSpc>
-              <a:spcAft>
-                <a:spcPts val="600"/>
-              </a:spcAft>
-              <a:buClr>
-                <a:srgbClr val="479FF8"/>
-              </a:buClr>
-              <a:buSzPct val="150000"/>
-              <a:buNone/>
-            </a:pPr>
-            <a:r>
-              <a:rPr lang="en-US" sz="1400" b="1" dirty="0">
-                <a:solidFill>
-                  <a:srgbClr val="1E5BB5"/>
-                </a:solidFill>
-                <a:latin typeface="Open Sans SemiBold" pitchFamily="2" charset="0"/>
-                <a:ea typeface="Open Sans SemiBold" pitchFamily="2" charset="0"/>
-                <a:cs typeface="Open Sans SemiBold" pitchFamily="2" charset="0"/>
-              </a:rPr>
-              <a:t>Slide subtitle</a:t>
-            </a:r>
-          </a:p>
-        </p:txBody>
-      </p:sp>
-      <p:sp>
-        <p:nvSpPr>
-          <p:cNvPr id="8" name="Footer Placeholder 4">
-            <a:extLst>
-              <a:ext uri="{FF2B5EF4-FFF2-40B4-BE49-F238E27FC236}">
-                <a16:creationId xmlns:a16="http://schemas.microsoft.com/office/drawing/2014/main" id="{CD32B7AD-73A8-00A3-C5D2-3206338E264D}"/>
-              </a:ext>
-            </a:extLst>
-          </p:cNvPr>
-          <p:cNvSpPr>
-            <a:spLocks noGrp="1"/>
-          </p:cNvSpPr>
-          <p:nvPr>
-            <p:ph type="ftr" sz="quarter" idx="3"/>
-          </p:nvPr>
-        </p:nvSpPr>
-        <p:spPr>
-          <a:xfrm>
-            <a:off x="540000" y="6461968"/>
-            <a:ext cx="3078186" cy="153888"/>
-          </a:xfrm>
-          <a:prstGeom prst="rect">
-            <a:avLst/>
-          </a:prstGeom>
-        </p:spPr>
-        <p:txBody>
-          <a:bodyPr vert="horz" wrap="square" lIns="0" tIns="0" rIns="0" bIns="0" rtlCol="0" anchor="ctr">
-            <a:spAutoFit/>
-          </a:bodyPr>
-          <a:lstStyle>
-            <a:lvl1pPr algn="l">
-              <a:defRPr sz="1000" b="0" i="0">
-                <a:solidFill>
-                  <a:srgbClr val="242D41"/>
-                </a:solidFill>
-                <a:latin typeface="Open Sans Light" panose="020B0306030504020204" pitchFamily="34" charset="0"/>
-                <a:ea typeface="Open Sans Light" panose="020B0306030504020204" pitchFamily="34" charset="0"/>
-                <a:cs typeface="Open Sans Light" panose="020B0306030504020204" pitchFamily="34" charset="0"/>
-              </a:defRPr>
-            </a:lvl1pPr>
-          </a:lstStyle>
-          <a:p>
-            <a:r>
-              <a:rPr lang="en-US" dirty="0"/>
-              <a:t>©</a:t>
-            </a:r>
-            <a:fld id="{3FEB6F09-2C38-294C-994A-AB349969DE87}" type="datetimeyyyy">
-              <a:rPr lang="en-GB" smtClean="0"/>
-              <a:pPr/>
-              <a:t>2026</a:t>
-            </a:fld>
-            <a:r>
-              <a:rPr lang="en-US" dirty="0"/>
-              <a:t> </a:t>
-            </a:r>
-            <a:r>
-              <a:rPr lang="en-US" dirty="0" err="1"/>
-              <a:t>TrustFlight</a:t>
-            </a:r>
-            <a:r>
-              <a:rPr lang="en-US" dirty="0"/>
-              <a:t> Ltd. All rights reserved. </a:t>
-            </a:r>
-          </a:p>
-        </p:txBody>
-      </p:sp>
-    </p:spTree>
-    <p:extLst>
-      <p:ext uri="{BB962C8B-B14F-4D97-AF65-F5344CB8AC3E}">
-        <p14:creationId xmlns:p14="http://schemas.microsoft.com/office/powerpoint/2010/main" val="3379980577"/>
       </p:ext>
     </p:extLst>
   </p:cSld>
@@ -9860,6 +10037,399 @@
       </p:grpSpPr>
       <p:sp>
         <p:nvSpPr>
+          <p:cNvPr id="2" name="Title 1">
+            <a:extLst>
+              <a:ext uri="{FF2B5EF4-FFF2-40B4-BE49-F238E27FC236}">
+                <a16:creationId xmlns:a16="http://schemas.microsoft.com/office/drawing/2014/main" id="{D7142FB2-D27B-8EA1-E477-92FB93D5906E}"/>
+              </a:ext>
+            </a:extLst>
+          </p:cNvPr>
+          <p:cNvSpPr>
+            <a:spLocks noGrp="1"/>
+          </p:cNvSpPr>
+          <p:nvPr>
+            <p:ph type="title"/>
+          </p:nvPr>
+        </p:nvSpPr>
+        <p:spPr>
+          <a:xfrm>
+            <a:off x="540000" y="774000"/>
+            <a:ext cx="9462670" cy="553998"/>
+          </a:xfrm>
+        </p:spPr>
+        <p:txBody>
+          <a:bodyPr/>
+          <a:lstStyle/>
+          <a:p>
+            <a:r>
+              <a:rPr lang="en-US" sz="4000" dirty="0"/>
+              <a:t>Slide Title</a:t>
+            </a:r>
+          </a:p>
+        </p:txBody>
+      </p:sp>
+      <p:sp>
+        <p:nvSpPr>
+          <p:cNvPr id="5" name="Slide Number Placeholder 4">
+            <a:extLst>
+              <a:ext uri="{FF2B5EF4-FFF2-40B4-BE49-F238E27FC236}">
+                <a16:creationId xmlns:a16="http://schemas.microsoft.com/office/drawing/2014/main" id="{68562A10-B3FE-CCD6-3B68-053CD49D0462}"/>
+              </a:ext>
+            </a:extLst>
+          </p:cNvPr>
+          <p:cNvSpPr>
+            <a:spLocks noGrp="1"/>
+          </p:cNvSpPr>
+          <p:nvPr>
+            <p:ph type="sldNum" sz="quarter" idx="4"/>
+          </p:nvPr>
+        </p:nvSpPr>
+        <p:spPr/>
+        <p:txBody>
+          <a:bodyPr/>
+          <a:lstStyle/>
+          <a:p>
+            <a:fld id="{1B377F6A-2966-294D-95D7-FBB58FDBE7CB}" type="slidenum">
+              <a:rPr lang="en-US" smtClean="0"/>
+              <a:pPr/>
+              <a:t>7</a:t>
+            </a:fld>
+            <a:endParaRPr lang="en-US"/>
+          </a:p>
+        </p:txBody>
+      </p:sp>
+      <p:sp>
+        <p:nvSpPr>
+          <p:cNvPr id="12" name="Content Placeholder 4">
+            <a:extLst>
+              <a:ext uri="{FF2B5EF4-FFF2-40B4-BE49-F238E27FC236}">
+                <a16:creationId xmlns:a16="http://schemas.microsoft.com/office/drawing/2014/main" id="{7A6A3014-D139-ED15-CA4C-45DFB26D1B85}"/>
+              </a:ext>
+            </a:extLst>
+          </p:cNvPr>
+          <p:cNvSpPr txBox="1">
+            <a:spLocks/>
+          </p:cNvSpPr>
+          <p:nvPr/>
+        </p:nvSpPr>
+        <p:spPr>
+          <a:xfrm>
+            <a:off x="540000" y="1382429"/>
+            <a:ext cx="6905829" cy="215444"/>
+          </a:xfrm>
+          <a:prstGeom prst="rect">
+            <a:avLst/>
+          </a:prstGeom>
+        </p:spPr>
+        <p:txBody>
+          <a:bodyPr vert="horz" wrap="square" lIns="0" tIns="0" rIns="0" bIns="0" rtlCol="0">
+            <a:spAutoFit/>
+          </a:bodyPr>
+          <a:lstStyle>
+            <a:lvl1pPr marL="228589" indent="-228589" algn="l" defTabSz="914355" rtl="0" eaLnBrk="1" latinLnBrk="0" hangingPunct="1">
+              <a:lnSpc>
+                <a:spcPct val="90000"/>
+              </a:lnSpc>
+              <a:spcBef>
+                <a:spcPts val="1000"/>
+              </a:spcBef>
+              <a:buClr>
+                <a:srgbClr val="1E5BB5"/>
+              </a:buClr>
+              <a:buFont typeface="Arial" panose="020B0604020202020204" pitchFamily="34" charset="0"/>
+              <a:buChar char="•"/>
+              <a:defRPr sz="2400" b="0" i="0" kern="1200">
+                <a:solidFill>
+                  <a:schemeClr val="bg1"/>
+                </a:solidFill>
+                <a:latin typeface="Open Sans Light" panose="020B0606030504020204" pitchFamily="34" charset="0"/>
+                <a:ea typeface="Open Sans Light" panose="020B0606030504020204" pitchFamily="34" charset="0"/>
+                <a:cs typeface="Open Sans Light" panose="020B0606030504020204" pitchFamily="34" charset="0"/>
+              </a:defRPr>
+            </a:lvl1pPr>
+            <a:lvl2pPr marL="685766" indent="-228589" algn="l" defTabSz="914355" rtl="0" eaLnBrk="1" latinLnBrk="0" hangingPunct="1">
+              <a:lnSpc>
+                <a:spcPct val="90000"/>
+              </a:lnSpc>
+              <a:spcBef>
+                <a:spcPts val="500"/>
+              </a:spcBef>
+              <a:buClr>
+                <a:srgbClr val="1E5BB5"/>
+              </a:buClr>
+              <a:buFont typeface="Arial" panose="020B0604020202020204" pitchFamily="34" charset="0"/>
+              <a:buChar char="•"/>
+              <a:defRPr sz="1400" b="0" i="0" kern="1200">
+                <a:solidFill>
+                  <a:srgbClr val="E0E8F7"/>
+                </a:solidFill>
+                <a:latin typeface="Open Sans Light" panose="020B0606030504020204" pitchFamily="34" charset="0"/>
+                <a:ea typeface="Open Sans Light" panose="020B0606030504020204" pitchFamily="34" charset="0"/>
+                <a:cs typeface="Open Sans Light" panose="020B0606030504020204" pitchFamily="34" charset="0"/>
+              </a:defRPr>
+            </a:lvl2pPr>
+            <a:lvl3pPr marL="1142943" indent="-228589" algn="l" defTabSz="914355" rtl="0" eaLnBrk="1" latinLnBrk="0" hangingPunct="1">
+              <a:lnSpc>
+                <a:spcPct val="90000"/>
+              </a:lnSpc>
+              <a:spcBef>
+                <a:spcPts val="500"/>
+              </a:spcBef>
+              <a:buClr>
+                <a:srgbClr val="1E5BB5"/>
+              </a:buClr>
+              <a:buFont typeface="Arial" panose="020B0604020202020204" pitchFamily="34" charset="0"/>
+              <a:buChar char="•"/>
+              <a:defRPr sz="1400" b="0" i="0" kern="1200">
+                <a:solidFill>
+                  <a:srgbClr val="E0E8F7"/>
+                </a:solidFill>
+                <a:latin typeface="Open Sans Light" panose="020B0606030504020204" pitchFamily="34" charset="0"/>
+                <a:ea typeface="Open Sans Light" panose="020B0606030504020204" pitchFamily="34" charset="0"/>
+                <a:cs typeface="Open Sans Light" panose="020B0606030504020204" pitchFamily="34" charset="0"/>
+              </a:defRPr>
+            </a:lvl3pPr>
+            <a:lvl4pPr marL="1600120" indent="-228589" algn="l" defTabSz="914355" rtl="0" eaLnBrk="1" latinLnBrk="0" hangingPunct="1">
+              <a:lnSpc>
+                <a:spcPct val="90000"/>
+              </a:lnSpc>
+              <a:spcBef>
+                <a:spcPts val="500"/>
+              </a:spcBef>
+              <a:buClr>
+                <a:srgbClr val="1E5BB5"/>
+              </a:buClr>
+              <a:buFont typeface="Arial" panose="020B0604020202020204" pitchFamily="34" charset="0"/>
+              <a:buChar char="•"/>
+              <a:defRPr sz="1400" b="0" i="0" kern="1200">
+                <a:solidFill>
+                  <a:srgbClr val="E0E8F7"/>
+                </a:solidFill>
+                <a:latin typeface="Open Sans Light" panose="020B0606030504020204" pitchFamily="34" charset="0"/>
+                <a:ea typeface="Open Sans Light" panose="020B0606030504020204" pitchFamily="34" charset="0"/>
+                <a:cs typeface="Open Sans Light" panose="020B0606030504020204" pitchFamily="34" charset="0"/>
+              </a:defRPr>
+            </a:lvl4pPr>
+            <a:lvl5pPr marL="2057297" indent="-228589" algn="l" defTabSz="914355" rtl="0" eaLnBrk="1" latinLnBrk="0" hangingPunct="1">
+              <a:lnSpc>
+                <a:spcPct val="90000"/>
+              </a:lnSpc>
+              <a:spcBef>
+                <a:spcPts val="500"/>
+              </a:spcBef>
+              <a:buClr>
+                <a:srgbClr val="1E5BB5"/>
+              </a:buClr>
+              <a:buFont typeface="Arial" panose="020B0604020202020204" pitchFamily="34" charset="0"/>
+              <a:buChar char="•"/>
+              <a:defRPr sz="1400" b="0" i="0" kern="1200">
+                <a:solidFill>
+                  <a:srgbClr val="E0E8F7"/>
+                </a:solidFill>
+                <a:latin typeface="Open Sans Light" panose="020B0606030504020204" pitchFamily="34" charset="0"/>
+                <a:ea typeface="Open Sans Light" panose="020B0606030504020204" pitchFamily="34" charset="0"/>
+                <a:cs typeface="Open Sans Light" panose="020B0606030504020204" pitchFamily="34" charset="0"/>
+              </a:defRPr>
+            </a:lvl5pPr>
+            <a:lvl6pPr marL="2514475" indent="-228589" algn="l" defTabSz="914355" rtl="0" eaLnBrk="1" latinLnBrk="0" hangingPunct="1">
+              <a:lnSpc>
+                <a:spcPct val="90000"/>
+              </a:lnSpc>
+              <a:spcBef>
+                <a:spcPts val="500"/>
+              </a:spcBef>
+              <a:buFont typeface="Arial" panose="020B0604020202020204" pitchFamily="34" charset="0"/>
+              <a:buChar char="•"/>
+              <a:defRPr sz="1800" kern="1200">
+                <a:solidFill>
+                  <a:schemeClr val="tx1"/>
+                </a:solidFill>
+                <a:latin typeface="+mn-lt"/>
+                <a:ea typeface="+mn-ea"/>
+                <a:cs typeface="+mn-cs"/>
+              </a:defRPr>
+            </a:lvl6pPr>
+            <a:lvl7pPr marL="2971652" indent="-228589" algn="l" defTabSz="914355" rtl="0" eaLnBrk="1" latinLnBrk="0" hangingPunct="1">
+              <a:lnSpc>
+                <a:spcPct val="90000"/>
+              </a:lnSpc>
+              <a:spcBef>
+                <a:spcPts val="500"/>
+              </a:spcBef>
+              <a:buFont typeface="Arial" panose="020B0604020202020204" pitchFamily="34" charset="0"/>
+              <a:buChar char="•"/>
+              <a:defRPr sz="1800" kern="1200">
+                <a:solidFill>
+                  <a:schemeClr val="tx1"/>
+                </a:solidFill>
+                <a:latin typeface="+mn-lt"/>
+                <a:ea typeface="+mn-ea"/>
+                <a:cs typeface="+mn-cs"/>
+              </a:defRPr>
+            </a:lvl7pPr>
+            <a:lvl8pPr marL="3428829" indent="-228589" algn="l" defTabSz="914355" rtl="0" eaLnBrk="1" latinLnBrk="0" hangingPunct="1">
+              <a:lnSpc>
+                <a:spcPct val="90000"/>
+              </a:lnSpc>
+              <a:spcBef>
+                <a:spcPts val="500"/>
+              </a:spcBef>
+              <a:buFont typeface="Arial" panose="020B0604020202020204" pitchFamily="34" charset="0"/>
+              <a:buChar char="•"/>
+              <a:defRPr sz="1800" kern="1200">
+                <a:solidFill>
+                  <a:schemeClr val="tx1"/>
+                </a:solidFill>
+                <a:latin typeface="+mn-lt"/>
+                <a:ea typeface="+mn-ea"/>
+                <a:cs typeface="+mn-cs"/>
+              </a:defRPr>
+            </a:lvl8pPr>
+            <a:lvl9pPr marL="3886006" indent="-228589" algn="l" defTabSz="914355" rtl="0" eaLnBrk="1" latinLnBrk="0" hangingPunct="1">
+              <a:lnSpc>
+                <a:spcPct val="90000"/>
+              </a:lnSpc>
+              <a:spcBef>
+                <a:spcPts val="500"/>
+              </a:spcBef>
+              <a:buFont typeface="Arial" panose="020B0604020202020204" pitchFamily="34" charset="0"/>
+              <a:buChar char="•"/>
+              <a:defRPr sz="1800" kern="1200">
+                <a:solidFill>
+                  <a:schemeClr val="tx1"/>
+                </a:solidFill>
+                <a:latin typeface="+mn-lt"/>
+                <a:ea typeface="+mn-ea"/>
+                <a:cs typeface="+mn-cs"/>
+              </a:defRPr>
+            </a:lvl9pPr>
+          </a:lstStyle>
+          <a:p>
+            <a:pPr marL="0" indent="0">
+              <a:lnSpc>
+                <a:spcPct val="100000"/>
+              </a:lnSpc>
+              <a:spcAft>
+                <a:spcPts val="600"/>
+              </a:spcAft>
+              <a:buClr>
+                <a:srgbClr val="479FF8"/>
+              </a:buClr>
+              <a:buSzPct val="150000"/>
+              <a:buNone/>
+            </a:pPr>
+            <a:r>
+              <a:rPr lang="en-US" sz="1400" b="1" dirty="0">
+                <a:solidFill>
+                  <a:srgbClr val="1E5BB5"/>
+                </a:solidFill>
+                <a:latin typeface="Open Sans SemiBold" pitchFamily="2" charset="0"/>
+                <a:ea typeface="Open Sans SemiBold" pitchFamily="2" charset="0"/>
+                <a:cs typeface="Open Sans SemiBold" pitchFamily="2" charset="0"/>
+              </a:rPr>
+              <a:t>Slide subtitle</a:t>
+            </a:r>
+          </a:p>
+        </p:txBody>
+      </p:sp>
+      <p:sp>
+        <p:nvSpPr>
+          <p:cNvPr id="8" name="Footer Placeholder 4">
+            <a:extLst>
+              <a:ext uri="{FF2B5EF4-FFF2-40B4-BE49-F238E27FC236}">
+                <a16:creationId xmlns:a16="http://schemas.microsoft.com/office/drawing/2014/main" id="{CD32B7AD-73A8-00A3-C5D2-3206338E264D}"/>
+              </a:ext>
+            </a:extLst>
+          </p:cNvPr>
+          <p:cNvSpPr>
+            <a:spLocks noGrp="1"/>
+          </p:cNvSpPr>
+          <p:nvPr>
+            <p:ph type="ftr" sz="quarter" idx="3"/>
+          </p:nvPr>
+        </p:nvSpPr>
+        <p:spPr>
+          <a:xfrm>
+            <a:off x="540000" y="6461968"/>
+            <a:ext cx="3078186" cy="153888"/>
+          </a:xfrm>
+          <a:prstGeom prst="rect">
+            <a:avLst/>
+          </a:prstGeom>
+        </p:spPr>
+        <p:txBody>
+          <a:bodyPr vert="horz" wrap="square" lIns="0" tIns="0" rIns="0" bIns="0" rtlCol="0" anchor="ctr">
+            <a:spAutoFit/>
+          </a:bodyPr>
+          <a:lstStyle>
+            <a:lvl1pPr algn="l">
+              <a:defRPr sz="1000" b="0" i="0">
+                <a:solidFill>
+                  <a:srgbClr val="242D41"/>
+                </a:solidFill>
+                <a:latin typeface="Open Sans Light" panose="020B0306030504020204" pitchFamily="34" charset="0"/>
+                <a:ea typeface="Open Sans Light" panose="020B0306030504020204" pitchFamily="34" charset="0"/>
+                <a:cs typeface="Open Sans Light" panose="020B0306030504020204" pitchFamily="34" charset="0"/>
+              </a:defRPr>
+            </a:lvl1pPr>
+          </a:lstStyle>
+          <a:p>
+            <a:r>
+              <a:rPr lang="en-US" dirty="0"/>
+              <a:t>©</a:t>
+            </a:r>
+            <a:fld id="{3FEB6F09-2C38-294C-994A-AB349969DE87}" type="datetimeyyyy">
+              <a:rPr lang="en-GB" smtClean="0"/>
+              <a:pPr/>
+              <a:t>2026</a:t>
+            </a:fld>
+            <a:r>
+              <a:rPr lang="en-US" dirty="0"/>
+              <a:t> </a:t>
+            </a:r>
+            <a:r>
+              <a:rPr lang="en-US" dirty="0" err="1"/>
+              <a:t>TrustFlight</a:t>
+            </a:r>
+            <a:r>
+              <a:rPr lang="en-US" dirty="0"/>
+              <a:t> Ltd. All rights reserved. </a:t>
+            </a:r>
+          </a:p>
+        </p:txBody>
+      </p:sp>
+    </p:spTree>
+    <p:extLst>
+      <p:ext uri="{BB962C8B-B14F-4D97-AF65-F5344CB8AC3E}">
+        <p14:creationId xmlns:p14="http://schemas.microsoft.com/office/powerpoint/2010/main" val="3379980577"/>
+      </p:ext>
+    </p:extLst>
+  </p:cSld>
+  <p:clrMapOvr>
+    <a:masterClrMapping/>
+  </p:clrMapOvr>
+</p:sld>
+</file>
+
+<file path=ppt/slides/slide8.xml><?xml version="1.0" encoding="utf-8"?>
+<p:sld xmlns:a="http://schemas.openxmlformats.org/drawingml/2006/main" xmlns:r="http://schemas.openxmlformats.org/officeDocument/2006/relationships" xmlns:p="http://schemas.openxmlformats.org/presentationml/2006/main">
+  <p:cSld>
+    <p:spTree>
+      <p:nvGrpSpPr>
+        <p:cNvPr id="1" name=""/>
+        <p:cNvGrpSpPr/>
+        <p:nvPr/>
+      </p:nvGrpSpPr>
+      <p:grpSpPr>
+        <a:xfrm>
+          <a:off x="0" y="0"/>
+          <a:ext cx="0" cy="0"/>
+          <a:chOff x="0" y="0"/>
+          <a:chExt cx="0" cy="0"/>
+        </a:xfrm>
+      </p:grpSpPr>
+      <p:sp>
+        <p:nvSpPr>
           <p:cNvPr id="6" name="Title 1">
             <a:extLst>
               <a:ext uri="{FF2B5EF4-FFF2-40B4-BE49-F238E27FC236}">
@@ -9945,10 +10515,10 @@
       </p:pic>
       <p:sp>
         <p:nvSpPr>
-          <p:cNvPr id="9" name="Content Placeholder 4">
-            <a:extLst>
-              <a:ext uri="{FF2B5EF4-FFF2-40B4-BE49-F238E27FC236}">
-                <a16:creationId xmlns:a16="http://schemas.microsoft.com/office/drawing/2014/main" id="{15148AE0-FB22-4991-0CAB-420C5BDD2588}"/>
+          <p:cNvPr id="13" name="Content Placeholder 4">
+            <a:extLst>
+              <a:ext uri="{FF2B5EF4-FFF2-40B4-BE49-F238E27FC236}">
+                <a16:creationId xmlns:a16="http://schemas.microsoft.com/office/drawing/2014/main" id="{29519188-0C7D-3726-B7FE-3F8C2C5B80F7}"/>
               </a:ext>
             </a:extLst>
           </p:cNvPr>
@@ -9959,8 +10529,8 @@
         </p:nvSpPr>
         <p:spPr>
           <a:xfrm>
-            <a:off x="1167864" y="4590545"/>
-            <a:ext cx="9591957" cy="923330"/>
+            <a:off x="1167864" y="4640978"/>
+            <a:ext cx="9132205" cy="1092607"/>
           </a:xfrm>
           <a:prstGeom prst="rect">
             <a:avLst/>
@@ -10184,7 +10754,7 @@
                 <a:ea typeface="Open Sans ExtraBold" pitchFamily="2" charset="0"/>
                 <a:cs typeface="Open Sans ExtraBold" pitchFamily="2" charset="0"/>
               </a:rPr>
-              <a:t>TrustFlight is a global technology innovator dedicated to accelerating digital transformation in aerospace and aviation.</a:t>
+              <a:t>TrustFlight is the Aerospace Safety Intelligence Platform, integrating safety and security technology, training and consulting, and crisis management and response into a single connected ecosystem.</a:t>
             </a:r>
           </a:p>
           <a:p>
@@ -10208,15 +10778,7 @@
               <a:defRPr/>
             </a:pPr>
             <a:r>
-              <a:rPr lang="en-US" sz="1100" dirty="0">
-                <a:solidFill>
-                  <a:srgbClr val="CFE2F3"/>
-                </a:solidFill>
-              </a:rPr>
-              <a:t>S</a:t>
-            </a:r>
-            <a:r>
-              <a:rPr kumimoji="0" lang="en-US" sz="1100" b="0" i="0" u="none" strike="noStrike" kern="1200" cap="none" spc="0" normalizeH="0" baseline="0" noProof="0" dirty="0" err="1">
+              <a:rPr kumimoji="0" lang="en-US" sz="1100" u="none" strike="noStrike" kern="1200" cap="none" spc="0" normalizeH="0" baseline="0" noProof="0" dirty="0">
                 <a:ln>
                   <a:noFill/>
                 </a:ln>
@@ -10226,14 +10788,14 @@
                 <a:effectLst/>
                 <a:uLnTx/>
                 <a:uFillTx/>
-                <a:latin typeface="Open Sans Light" panose="020B0606030504020204" pitchFamily="34" charset="0"/>
-                <a:ea typeface="Open Sans Light" panose="020B0606030504020204" pitchFamily="34" charset="0"/>
-                <a:cs typeface="Open Sans Light" panose="020B0606030504020204" pitchFamily="34" charset="0"/>
+                <a:latin typeface="Open Sans Light" pitchFamily="2" charset="0"/>
+                <a:ea typeface="Open Sans Light" pitchFamily="2" charset="0"/>
+                <a:cs typeface="Open Sans Light" pitchFamily="2" charset="0"/>
               </a:rPr>
-              <a:t>erving</a:t>
-            </a:r>
-            <a:r>
-              <a:rPr kumimoji="0" lang="en-US" sz="1100" b="0" i="0" u="none" strike="noStrike" kern="1200" cap="none" spc="0" normalizeH="0" baseline="0" noProof="0" dirty="0">
+              <a:t>Serving more than 1,600 </a:t>
+            </a:r>
+            <a:r>
+              <a:rPr kumimoji="0" lang="en-US" sz="1100" u="none" strike="noStrike" kern="1200" cap="none" spc="0" normalizeH="0" baseline="0" noProof="0" dirty="0" err="1">
                 <a:ln>
                   <a:noFill/>
                 </a:ln>
@@ -10243,21 +10805,72 @@
                 <a:effectLst/>
                 <a:uLnTx/>
                 <a:uFillTx/>
-                <a:latin typeface="Open Sans Light" panose="020B0606030504020204" pitchFamily="34" charset="0"/>
-                <a:ea typeface="Open Sans Light" panose="020B0606030504020204" pitchFamily="34" charset="0"/>
-                <a:cs typeface="Open Sans Light" panose="020B0606030504020204" pitchFamily="34" charset="0"/>
+                <a:latin typeface="Open Sans Light" pitchFamily="2" charset="0"/>
+                <a:ea typeface="Open Sans Light" pitchFamily="2" charset="0"/>
+                <a:cs typeface="Open Sans Light" pitchFamily="2" charset="0"/>
               </a:rPr>
-              <a:t> over 200,000 active users worldwide across 1,600+ customers, TrustFlight provides leading-edge software and services to every segment of aviation, including airports, operators, MROs, regulators, and more. Its robust portfolio includes powerful SaaS workflow automation platforms, groundbreaking agentic AI technologies, comprehensive CAMO services, as well as expert AOC consulting and Manual Revision Services. TrustFlight partners with airports, operators, MROs, regulatory authorities, and aviation professionals to drive innovation and set new standards of excellence.</a:t>
+              <a:t>organisations</a:t>
+            </a:r>
+            <a:r>
+              <a:rPr kumimoji="0" lang="en-US" sz="1100" u="none" strike="noStrike" kern="1200" cap="none" spc="0" normalizeH="0" baseline="0" noProof="0" dirty="0">
+                <a:ln>
+                  <a:noFill/>
+                </a:ln>
+                <a:solidFill>
+                  <a:srgbClr val="CFE2F3"/>
+                </a:solidFill>
+                <a:effectLst/>
+                <a:uLnTx/>
+                <a:uFillTx/>
+                <a:latin typeface="Open Sans Light" pitchFamily="2" charset="0"/>
+                <a:ea typeface="Open Sans Light" pitchFamily="2" charset="0"/>
+                <a:cs typeface="Open Sans Light" pitchFamily="2" charset="0"/>
+              </a:rPr>
+              <a:t> in 120 countries, TrustFlight delivers operational intelligence and the expertise to act on it. The platform combines SaaS workflow automation, AI-driven regulatory intelligence, and 24/7 crisis response to support airports, operators, MROs, OEMs, and regulators. TrustFlight helps aviation </a:t>
+            </a:r>
+            <a:r>
+              <a:rPr kumimoji="0" lang="en-US" sz="1100" u="none" strike="noStrike" kern="1200" cap="none" spc="0" normalizeH="0" baseline="0" noProof="0" dirty="0" err="1">
+                <a:ln>
+                  <a:noFill/>
+                </a:ln>
+                <a:solidFill>
+                  <a:srgbClr val="CFE2F3"/>
+                </a:solidFill>
+                <a:effectLst/>
+                <a:uLnTx/>
+                <a:uFillTx/>
+                <a:latin typeface="Open Sans Light" pitchFamily="2" charset="0"/>
+                <a:ea typeface="Open Sans Light" pitchFamily="2" charset="0"/>
+                <a:cs typeface="Open Sans Light" pitchFamily="2" charset="0"/>
+              </a:rPr>
+              <a:t>organisations</a:t>
+            </a:r>
+            <a:r>
+              <a:rPr kumimoji="0" lang="en-US" sz="1100" u="none" strike="noStrike" kern="1200" cap="none" spc="0" normalizeH="0" baseline="0" noProof="0" dirty="0">
+                <a:ln>
+                  <a:noFill/>
+                </a:ln>
+                <a:solidFill>
+                  <a:srgbClr val="CFE2F3"/>
+                </a:solidFill>
+                <a:effectLst/>
+                <a:uLnTx/>
+                <a:uFillTx/>
+                <a:latin typeface="Open Sans Light" pitchFamily="2" charset="0"/>
+                <a:ea typeface="Open Sans Light" pitchFamily="2" charset="0"/>
+                <a:cs typeface="Open Sans Light" pitchFamily="2" charset="0"/>
+              </a:rPr>
+              <a:t> close critical gaps between disconnected tools and providers, where risk can accumulate. To learn more, please visit our website.</a:t>
             </a:r>
           </a:p>
         </p:txBody>
       </p:sp>
       <p:grpSp>
         <p:nvGrpSpPr>
-          <p:cNvPr id="2" name="Group 1">
-            <a:extLst>
-              <a:ext uri="{FF2B5EF4-FFF2-40B4-BE49-F238E27FC236}">
-                <a16:creationId xmlns:a16="http://schemas.microsoft.com/office/drawing/2014/main" id="{2DFCEA43-7068-26FC-2B37-ED1E9E2C47E0}"/>
+          <p:cNvPr id="14" name="Group 13">
+            <a:extLst>
+              <a:ext uri="{FF2B5EF4-FFF2-40B4-BE49-F238E27FC236}">
+                <a16:creationId xmlns:a16="http://schemas.microsoft.com/office/drawing/2014/main" id="{7AC5DB8F-AA3F-928F-E496-2AE80C8D6667}"/>
               </a:ext>
             </a:extLst>
           </p:cNvPr>
@@ -10266,7 +10879,7 @@
         </p:nvGrpSpPr>
         <p:grpSpPr>
           <a:xfrm>
-            <a:off x="1167864" y="5730503"/>
+            <a:off x="1167864" y="5944243"/>
             <a:ext cx="8218241" cy="470197"/>
             <a:chOff x="1167864" y="5797775"/>
             <a:chExt cx="8218241" cy="470197"/>
@@ -10274,11 +10887,11 @@
         </p:grpSpPr>
         <p:sp>
           <p:nvSpPr>
-            <p:cNvPr id="3" name="Rounded Rectangle 2">
+            <p:cNvPr id="15" name="Rounded Rectangle 14">
               <a:hlinkClick r:id="rId3"/>
               <a:extLst>
                 <a:ext uri="{FF2B5EF4-FFF2-40B4-BE49-F238E27FC236}">
-                  <a16:creationId xmlns:a16="http://schemas.microsoft.com/office/drawing/2014/main" id="{108D0804-1A6E-562B-14AE-AFCDD7121DFD}"/>
+                  <a16:creationId xmlns:a16="http://schemas.microsoft.com/office/drawing/2014/main" id="{51A09357-9F64-4603-5B9A-1E1DB8F5DA50}"/>
                 </a:ext>
               </a:extLst>
             </p:cNvPr>
@@ -10351,11 +10964,11 @@
         </p:sp>
         <p:sp>
           <p:nvSpPr>
-            <p:cNvPr id="4" name="Rounded Rectangle 3">
+            <p:cNvPr id="16" name="Rounded Rectangle 15">
               <a:hlinkClick r:id="rId4"/>
               <a:extLst>
                 <a:ext uri="{FF2B5EF4-FFF2-40B4-BE49-F238E27FC236}">
-                  <a16:creationId xmlns:a16="http://schemas.microsoft.com/office/drawing/2014/main" id="{83415C92-0C71-93FE-9531-0DFCFFDB10A8}"/>
+                  <a16:creationId xmlns:a16="http://schemas.microsoft.com/office/drawing/2014/main" id="{B95A95BD-EC0B-E20A-AB3B-CFE394F688DD}"/>
                 </a:ext>
               </a:extLst>
             </p:cNvPr>
@@ -10422,10 +11035,10 @@
         </p:sp>
         <p:sp>
           <p:nvSpPr>
-            <p:cNvPr id="5" name="Rounded Rectangle 4">
+            <p:cNvPr id="17" name="Rounded Rectangle 16">
               <a:extLst>
                 <a:ext uri="{FF2B5EF4-FFF2-40B4-BE49-F238E27FC236}">
-                  <a16:creationId xmlns:a16="http://schemas.microsoft.com/office/drawing/2014/main" id="{F8111922-8256-1298-7BA3-472ABD50CB79}"/>
+                  <a16:creationId xmlns:a16="http://schemas.microsoft.com/office/drawing/2014/main" id="{AD418364-C0A7-69A2-13F9-7FC005B03B7D}"/>
                 </a:ext>
               </a:extLst>
             </p:cNvPr>
@@ -10490,10 +11103,10 @@
         </p:sp>
         <p:grpSp>
           <p:nvGrpSpPr>
-            <p:cNvPr id="10" name="Group 9">
+            <p:cNvPr id="18" name="Group 17">
               <a:extLst>
                 <a:ext uri="{FF2B5EF4-FFF2-40B4-BE49-F238E27FC236}">
-                  <a16:creationId xmlns:a16="http://schemas.microsoft.com/office/drawing/2014/main" id="{7AD73A09-974B-EFF4-8C39-60A03578CF81}"/>
+                  <a16:creationId xmlns:a16="http://schemas.microsoft.com/office/drawing/2014/main" id="{9A16970B-3CE6-BEA5-A533-0C72B1944113}"/>
                 </a:ext>
               </a:extLst>
             </p:cNvPr>
@@ -10510,11 +11123,11 @@
           </p:grpSpPr>
           <p:sp>
             <p:nvSpPr>
-              <p:cNvPr id="11" name="Rounded Rectangle 10">
+              <p:cNvPr id="19" name="Rounded Rectangle 18">
                 <a:hlinkClick r:id="rId5"/>
                 <a:extLst>
                   <a:ext uri="{FF2B5EF4-FFF2-40B4-BE49-F238E27FC236}">
-                    <a16:creationId xmlns:a16="http://schemas.microsoft.com/office/drawing/2014/main" id="{3C50C86C-ABF2-2A7B-7C10-8C5228754046}"/>
+                    <a16:creationId xmlns:a16="http://schemas.microsoft.com/office/drawing/2014/main" id="{B9074B3A-9AAB-4B1D-B148-E475D5A0D4D6}"/>
                   </a:ext>
                 </a:extLst>
               </p:cNvPr>
@@ -10573,10 +11186,10 @@
           </p:sp>
           <p:pic>
             <p:nvPicPr>
-              <p:cNvPr id="12" name="Picture 11">
+              <p:cNvPr id="20" name="Picture 19">
                 <a:extLst>
                   <a:ext uri="{FF2B5EF4-FFF2-40B4-BE49-F238E27FC236}">
-                    <a16:creationId xmlns:a16="http://schemas.microsoft.com/office/drawing/2014/main" id="{8B003DEB-D6A1-68A0-9AA8-A3936BEEF2D5}"/>
+                    <a16:creationId xmlns:a16="http://schemas.microsoft.com/office/drawing/2014/main" id="{C2E7F44C-6C6C-5141-0519-8EF305BFEFA1}"/>
                   </a:ext>
                 </a:extLst>
               </p:cNvPr>

</xml_diff>